<commit_message>
feat: add challenge cup hard evidence ledger
</commit_message>
<xml_diff>
--- a/docs/challenge_cup/defense_deck/challenge_cup_defense_deck.pptx
+++ b/docs/challenge_cup/defense_deck/challenge_cup_defense_deck.pptx
@@ -2,22 +2,22 @@
 <file path=ppt/presentation.xml><?xml version="1.0" encoding="utf-8"?>
 <p:presentation xmlns:p="http://schemas.openxmlformats.org/presentationml/2006/main">
   <p:sldMasterIdLst>
-    <p:sldMasterId xmlns:r="http://schemas.openxmlformats.org/officeDocument/2006/relationships" id="2147483648" r:id="R22e17306c11a4561"/>
+    <p:sldMasterId xmlns:r="http://schemas.openxmlformats.org/officeDocument/2006/relationships" id="2147483648" r:id="R6ce22353450841eb"/>
   </p:sldMasterIdLst>
   <p:notesMasterIdLst>
-    <p:notesMasterId xmlns:r="http://schemas.openxmlformats.org/officeDocument/2006/relationships" r:id="Re2b7d58fd83441b8"/>
+    <p:notesMasterId xmlns:r="http://schemas.openxmlformats.org/officeDocument/2006/relationships" r:id="R9b94fee5a8c24ea9"/>
   </p:notesMasterIdLst>
   <p:sldIdLst>
-    <p:sldId xmlns:r="http://schemas.openxmlformats.org/officeDocument/2006/relationships" id="256" r:id="R95ad4c46cfa3458f"/>
-    <p:sldId xmlns:r="http://schemas.openxmlformats.org/officeDocument/2006/relationships" id="257" r:id="R8dd73c881d544994"/>
-    <p:sldId xmlns:r="http://schemas.openxmlformats.org/officeDocument/2006/relationships" id="258" r:id="R106c75a33b1040d0"/>
-    <p:sldId xmlns:r="http://schemas.openxmlformats.org/officeDocument/2006/relationships" id="259" r:id="R8959f1b694884842"/>
-    <p:sldId xmlns:r="http://schemas.openxmlformats.org/officeDocument/2006/relationships" id="260" r:id="R2ddca0af3ebe4e3c"/>
-    <p:sldId xmlns:r="http://schemas.openxmlformats.org/officeDocument/2006/relationships" id="261" r:id="R2c8c2fe1316d4e27"/>
-    <p:sldId xmlns:r="http://schemas.openxmlformats.org/officeDocument/2006/relationships" id="262" r:id="Rfeab32768c1d4361"/>
-    <p:sldId xmlns:r="http://schemas.openxmlformats.org/officeDocument/2006/relationships" id="263" r:id="R51b4f1967587424d"/>
-    <p:sldId xmlns:r="http://schemas.openxmlformats.org/officeDocument/2006/relationships" id="264" r:id="Rc55c42e6e4764c26"/>
-    <p:sldId xmlns:r="http://schemas.openxmlformats.org/officeDocument/2006/relationships" id="265" r:id="R3f7f11b3d0c4477a"/>
+    <p:sldId xmlns:r="http://schemas.openxmlformats.org/officeDocument/2006/relationships" id="256" r:id="Re35704fc4e0c44eb"/>
+    <p:sldId xmlns:r="http://schemas.openxmlformats.org/officeDocument/2006/relationships" id="257" r:id="Rd64da5ce722c40d1"/>
+    <p:sldId xmlns:r="http://schemas.openxmlformats.org/officeDocument/2006/relationships" id="258" r:id="R782adcfecb824a3d"/>
+    <p:sldId xmlns:r="http://schemas.openxmlformats.org/officeDocument/2006/relationships" id="259" r:id="R678e1546f7d94984"/>
+    <p:sldId xmlns:r="http://schemas.openxmlformats.org/officeDocument/2006/relationships" id="260" r:id="R4f685c30743446bd"/>
+    <p:sldId xmlns:r="http://schemas.openxmlformats.org/officeDocument/2006/relationships" id="261" r:id="R270bcfc2e9dc4f5a"/>
+    <p:sldId xmlns:r="http://schemas.openxmlformats.org/officeDocument/2006/relationships" id="262" r:id="R236fb267db1f44ed"/>
+    <p:sldId xmlns:r="http://schemas.openxmlformats.org/officeDocument/2006/relationships" id="263" r:id="R7ab38f17403140e1"/>
+    <p:sldId xmlns:r="http://schemas.openxmlformats.org/officeDocument/2006/relationships" id="264" r:id="R57e35b38a2ea4404"/>
+    <p:sldId xmlns:r="http://schemas.openxmlformats.org/officeDocument/2006/relationships" id="265" r:id="R87358644abe145de"/>
   </p:sldIdLst>
   <p:sldSz cx="12192000" cy="6858000"/>
   <p:notesSz cx="6858000" cy="9144000"/>
@@ -1158,7 +1158,7 @@
   </p:cSld>
   <p:clrMap bg1="lt1" tx1="dk1" bg2="lt2" tx2="dk2" accent1="accent1" accent2="accent2" accent3="accent3" accent4="accent4" accent5="accent5" accent6="accent6" hlink="hlink" folHlink="folHlink"/>
   <p:sldLayoutIdLst>
-    <p:sldLayoutId xmlns:r="http://schemas.openxmlformats.org/officeDocument/2006/relationships" id="2147483649" r:id="R4e6d26af2d6e4fe2"/>
+    <p:sldLayoutId xmlns:r="http://schemas.openxmlformats.org/officeDocument/2006/relationships" id="2147483649" r:id="R5038ddedea6b4446"/>
   </p:sldLayoutIdLst>
   <p:txStyles>
     <p:titleStyle>
@@ -1656,7 +1656,7 @@
           <p:cNvPr id="1" name="">
             <a:extLst xmlns:a="http://schemas.openxmlformats.org/drawingml/2006/main">
               <a:ext uri="{FF2B5EF4-FFF2-40B4-BE49-F238E27FC236}">
-                <a16:creationId xmlns:a16="http://schemas.microsoft.com/office/drawing/2014/main" id="{477D14A8-F668-4307-BF9D-1C578FC4B975}"/>
+                <a16:creationId xmlns:a16="http://schemas.microsoft.com/office/drawing/2014/main" id="{6D9AE620-1245-4C02-A857-A46DDA2891EF}"/>
               </a:ext>
             </a:extLst>
           </p:cNvPr>
@@ -1691,7 +1691,7 @@
           <p:cNvPr id="2" name="">
             <a:extLst xmlns:a="http://schemas.openxmlformats.org/drawingml/2006/main">
               <a:ext uri="{FF2B5EF4-FFF2-40B4-BE49-F238E27FC236}">
-                <a16:creationId xmlns:a16="http://schemas.microsoft.com/office/drawing/2014/main" id="{76022477-AD2C-4DD2-BAC1-0A7EED431047}"/>
+                <a16:creationId xmlns:a16="http://schemas.microsoft.com/office/drawing/2014/main" id="{6B01EECF-AD64-48A6-B841-80546A2889D1}"/>
               </a:ext>
             </a:extLst>
           </p:cNvPr>
@@ -1755,7 +1755,7 @@
           <p:cNvPr id="3" name="">
             <a:extLst xmlns:a="http://schemas.openxmlformats.org/drawingml/2006/main">
               <a:ext uri="{FF2B5EF4-FFF2-40B4-BE49-F238E27FC236}">
-                <a16:creationId xmlns:a16="http://schemas.microsoft.com/office/drawing/2014/main" id="{5AF461DB-DFF1-4CCB-B2C6-6B10C1518790}"/>
+                <a16:creationId xmlns:a16="http://schemas.microsoft.com/office/drawing/2014/main" id="{093EE6E8-D92B-4382-B2C1-4FC19A7BF46A}"/>
               </a:ext>
             </a:extLst>
           </p:cNvPr>
@@ -1819,7 +1819,7 @@
           <p:cNvPr id="4" name="">
             <a:extLst xmlns:a="http://schemas.openxmlformats.org/drawingml/2006/main">
               <a:ext uri="{FF2B5EF4-FFF2-40B4-BE49-F238E27FC236}">
-                <a16:creationId xmlns:a16="http://schemas.microsoft.com/office/drawing/2014/main" id="{2645BF31-79E9-4A8B-BD8C-49685D63A042}"/>
+                <a16:creationId xmlns:a16="http://schemas.microsoft.com/office/drawing/2014/main" id="{61A8E0D1-E98D-4D28-86FE-6F95518C0206}"/>
               </a:ext>
             </a:extLst>
           </p:cNvPr>
@@ -1883,7 +1883,7 @@
           <p:cNvPr id="5" name="">
             <a:extLst xmlns:a="http://schemas.openxmlformats.org/drawingml/2006/main">
               <a:ext uri="{FF2B5EF4-FFF2-40B4-BE49-F238E27FC236}">
-                <a16:creationId xmlns:a16="http://schemas.microsoft.com/office/drawing/2014/main" id="{3EF11111-1EBF-42DD-BED8-A47A02583B1C}"/>
+                <a16:creationId xmlns:a16="http://schemas.microsoft.com/office/drawing/2014/main" id="{420032D7-D502-4285-8E5B-EB7606B08310}"/>
               </a:ext>
             </a:extLst>
           </p:cNvPr>
@@ -1918,7 +1918,7 @@
           <p:cNvPr id="6" name="">
             <a:extLst xmlns:a="http://schemas.openxmlformats.org/drawingml/2006/main">
               <a:ext uri="{FF2B5EF4-FFF2-40B4-BE49-F238E27FC236}">
-                <a16:creationId xmlns:a16="http://schemas.microsoft.com/office/drawing/2014/main" id="{6701287C-4B8C-4EC7-927E-43EF22A0F2ED}"/>
+                <a16:creationId xmlns:a16="http://schemas.microsoft.com/office/drawing/2014/main" id="{B64FBDA9-AB37-4B85-9DBD-24B7051123ED}"/>
               </a:ext>
             </a:extLst>
           </p:cNvPr>
@@ -1982,7 +1982,7 @@
           <p:cNvPr id="7" name="">
             <a:extLst xmlns:a="http://schemas.openxmlformats.org/drawingml/2006/main">
               <a:ext uri="{FF2B5EF4-FFF2-40B4-BE49-F238E27FC236}">
-                <a16:creationId xmlns:a16="http://schemas.microsoft.com/office/drawing/2014/main" id="{4958EF7D-869D-4C65-B204-47A330E475CE}"/>
+                <a16:creationId xmlns:a16="http://schemas.microsoft.com/office/drawing/2014/main" id="{C198BD40-8EB0-4542-8046-4690D11F8D03}"/>
               </a:ext>
             </a:extLst>
           </p:cNvPr>
@@ -2046,7 +2046,7 @@
           <p:cNvPr id="8" name="">
             <a:extLst xmlns:a="http://schemas.openxmlformats.org/drawingml/2006/main">
               <a:ext uri="{FF2B5EF4-FFF2-40B4-BE49-F238E27FC236}">
-                <a16:creationId xmlns:a16="http://schemas.microsoft.com/office/drawing/2014/main" id="{A89481D8-ACFE-41B9-8E24-56DC8567989A}"/>
+                <a16:creationId xmlns:a16="http://schemas.microsoft.com/office/drawing/2014/main" id="{E8BD68DB-D88E-49D3-9FB3-9DDE21409CF3}"/>
               </a:ext>
             </a:extLst>
           </p:cNvPr>
@@ -2110,7 +2110,7 @@
           <p:cNvPr id="9" name="">
             <a:extLst xmlns:a="http://schemas.openxmlformats.org/drawingml/2006/main">
               <a:ext uri="{FF2B5EF4-FFF2-40B4-BE49-F238E27FC236}">
-                <a16:creationId xmlns:a16="http://schemas.microsoft.com/office/drawing/2014/main" id="{1B2D5F83-FCA0-4484-9D97-B8E831E04572}"/>
+                <a16:creationId xmlns:a16="http://schemas.microsoft.com/office/drawing/2014/main" id="{18C344F8-2246-4139-A6D7-3D4E40B145A7}"/>
               </a:ext>
             </a:extLst>
           </p:cNvPr>
@@ -2174,7 +2174,7 @@
           <p:cNvPr id="10" name="">
             <a:extLst xmlns:a="http://schemas.openxmlformats.org/drawingml/2006/main">
               <a:ext uri="{FF2B5EF4-FFF2-40B4-BE49-F238E27FC236}">
-                <a16:creationId xmlns:a16="http://schemas.microsoft.com/office/drawing/2014/main" id="{239B0C34-4A72-47D8-8869-92D03AA52648}"/>
+                <a16:creationId xmlns:a16="http://schemas.microsoft.com/office/drawing/2014/main" id="{D1C66FAA-F266-4BD0-B3F3-18412F2EF1EC}"/>
               </a:ext>
             </a:extLst>
           </p:cNvPr>
@@ -2238,7 +2238,7 @@
           <p:cNvPr id="11" name="">
             <a:extLst xmlns:a="http://schemas.openxmlformats.org/drawingml/2006/main">
               <a:ext uri="{FF2B5EF4-FFF2-40B4-BE49-F238E27FC236}">
-                <a16:creationId xmlns:a16="http://schemas.microsoft.com/office/drawing/2014/main" id="{F7FDE4DF-596C-4382-B75B-007516FFF807}"/>
+                <a16:creationId xmlns:a16="http://schemas.microsoft.com/office/drawing/2014/main" id="{6ED1D683-D6C7-412A-8A22-FF01284B00A4}"/>
               </a:ext>
             </a:extLst>
           </p:cNvPr>
@@ -2302,7 +2302,7 @@
           <p:cNvPr id="12" name="">
             <a:extLst xmlns:a="http://schemas.openxmlformats.org/drawingml/2006/main">
               <a:ext uri="{FF2B5EF4-FFF2-40B4-BE49-F238E27FC236}">
-                <a16:creationId xmlns:a16="http://schemas.microsoft.com/office/drawing/2014/main" id="{EAE39EE0-E8A3-4FDD-BAAA-725789A7DE99}"/>
+                <a16:creationId xmlns:a16="http://schemas.microsoft.com/office/drawing/2014/main" id="{D929D497-535E-4E54-A234-6F8D4D59EE65}"/>
               </a:ext>
             </a:extLst>
           </p:cNvPr>
@@ -2356,7 +2356,7 @@
                 <a:ea typeface="Aptos Display"/>
                 <a:cs typeface="Aptos Display"/>
               </a:rPr>
-              <a:t>48</a:t>
+              <a:t>Archive</a:t>
             </a:r>
           </a:p>
         </p:txBody>
@@ -2366,7 +2366,7 @@
           <p:cNvPr id="13" name="">
             <a:extLst xmlns:a="http://schemas.openxmlformats.org/drawingml/2006/main">
               <a:ext uri="{FF2B5EF4-FFF2-40B4-BE49-F238E27FC236}">
-                <a16:creationId xmlns:a16="http://schemas.microsoft.com/office/drawing/2014/main" id="{1FD2E9E1-332B-46A5-82F0-0CF9A7F92E4F}"/>
+                <a16:creationId xmlns:a16="http://schemas.microsoft.com/office/drawing/2014/main" id="{F416ED11-FA55-4771-92D4-11DA14D76469}"/>
               </a:ext>
             </a:extLst>
           </p:cNvPr>
@@ -2420,7 +2420,7 @@
                 <a:ea typeface="Microsoft YaHei"/>
                 <a:cs typeface="Microsoft YaHei"/>
               </a:rPr>
-              <a:t>归档包文件</a:t>
+              <a:t>manifest 记录</a:t>
             </a:r>
           </a:p>
         </p:txBody>
@@ -2430,7 +2430,7 @@
           <p:cNvPr id="14" name="">
             <a:extLst xmlns:a="http://schemas.openxmlformats.org/drawingml/2006/main">
               <a:ext uri="{FF2B5EF4-FFF2-40B4-BE49-F238E27FC236}">
-                <a16:creationId xmlns:a16="http://schemas.microsoft.com/office/drawing/2014/main" id="{6C75143F-C422-4AF5-A27C-057ACD368615}"/>
+                <a16:creationId xmlns:a16="http://schemas.microsoft.com/office/drawing/2014/main" id="{BF7C017F-C56C-4020-A020-BBF6D4311BF8}"/>
               </a:ext>
             </a:extLst>
           </p:cNvPr>
@@ -2494,7 +2494,7 @@
           <p:cNvPr id="15" name="">
             <a:extLst xmlns:a="http://schemas.openxmlformats.org/drawingml/2006/main">
               <a:ext uri="{FF2B5EF4-FFF2-40B4-BE49-F238E27FC236}">
-                <a16:creationId xmlns:a16="http://schemas.microsoft.com/office/drawing/2014/main" id="{4BDB6AD8-5EAB-4D07-ADFD-E0C1C69C932C}"/>
+                <a16:creationId xmlns:a16="http://schemas.microsoft.com/office/drawing/2014/main" id="{511B6500-1770-410C-9A2D-864A1BAE9A02}"/>
               </a:ext>
             </a:extLst>
           </p:cNvPr>
@@ -2558,7 +2558,7 @@
           <p:cNvPr id="16" name="">
             <a:extLst xmlns:a="http://schemas.openxmlformats.org/drawingml/2006/main">
               <a:ext uri="{FF2B5EF4-FFF2-40B4-BE49-F238E27FC236}">
-                <a16:creationId xmlns:a16="http://schemas.microsoft.com/office/drawing/2014/main" id="{A7F5A978-F7F5-4B35-9FDC-A03705ABA40E}"/>
+                <a16:creationId xmlns:a16="http://schemas.microsoft.com/office/drawing/2014/main" id="{3DCD01C0-2688-44F8-BA24-C9ED8C318626}"/>
               </a:ext>
             </a:extLst>
           </p:cNvPr>
@@ -2593,7 +2593,7 @@
           <p:cNvPr id="17" name="">
             <a:extLst xmlns:a="http://schemas.openxmlformats.org/drawingml/2006/main">
               <a:ext uri="{FF2B5EF4-FFF2-40B4-BE49-F238E27FC236}">
-                <a16:creationId xmlns:a16="http://schemas.microsoft.com/office/drawing/2014/main" id="{0BDC7E00-ABFF-4292-B85F-CD014275BE95}"/>
+                <a16:creationId xmlns:a16="http://schemas.microsoft.com/office/drawing/2014/main" id="{5B0CA4E6-D58A-4006-A2ED-DC189AFE7F39}"/>
               </a:ext>
             </a:extLst>
           </p:cNvPr>
@@ -2657,7 +2657,7 @@
           <p:cNvPr id="18" name="">
             <a:extLst xmlns:a="http://schemas.openxmlformats.org/drawingml/2006/main">
               <a:ext uri="{FF2B5EF4-FFF2-40B4-BE49-F238E27FC236}">
-                <a16:creationId xmlns:a16="http://schemas.microsoft.com/office/drawing/2014/main" id="{8FD48266-560D-4EFD-824D-985057975120}"/>
+                <a16:creationId xmlns:a16="http://schemas.microsoft.com/office/drawing/2014/main" id="{84DC25AD-7255-4C3C-A196-8196AA9D3617}"/>
               </a:ext>
             </a:extLst>
           </p:cNvPr>
@@ -2692,7 +2692,7 @@
           <p:cNvPr id="19" name="">
             <a:extLst xmlns:a="http://schemas.openxmlformats.org/drawingml/2006/main">
               <a:ext uri="{FF2B5EF4-FFF2-40B4-BE49-F238E27FC236}">
-                <a16:creationId xmlns:a16="http://schemas.microsoft.com/office/drawing/2014/main" id="{DEB230FA-9379-408F-97EC-AD814EA05FDA}"/>
+                <a16:creationId xmlns:a16="http://schemas.microsoft.com/office/drawing/2014/main" id="{8B2B5F7A-1BF4-4A8F-BCD9-2FC5F0A677B2}"/>
               </a:ext>
             </a:extLst>
           </p:cNvPr>
@@ -2756,7 +2756,7 @@
           <p:cNvPr id="20" name="">
             <a:extLst xmlns:a="http://schemas.openxmlformats.org/drawingml/2006/main">
               <a:ext uri="{FF2B5EF4-FFF2-40B4-BE49-F238E27FC236}">
-                <a16:creationId xmlns:a16="http://schemas.microsoft.com/office/drawing/2014/main" id="{9D8A68C2-391C-4048-A801-74C99F3F1D0D}"/>
+                <a16:creationId xmlns:a16="http://schemas.microsoft.com/office/drawing/2014/main" id="{75CAE2F5-7D2D-404E-8B77-13FC5E73CC64}"/>
               </a:ext>
             </a:extLst>
           </p:cNvPr>
@@ -2791,7 +2791,7 @@
           <p:cNvPr id="21" name="">
             <a:extLst xmlns:a="http://schemas.openxmlformats.org/drawingml/2006/main">
               <a:ext uri="{FF2B5EF4-FFF2-40B4-BE49-F238E27FC236}">
-                <a16:creationId xmlns:a16="http://schemas.microsoft.com/office/drawing/2014/main" id="{B48FE800-5ADE-48E7-B0B8-1B35C3043CC7}"/>
+                <a16:creationId xmlns:a16="http://schemas.microsoft.com/office/drawing/2014/main" id="{9818D3B0-E296-4561-AE29-6CA7DFDCEF14}"/>
               </a:ext>
             </a:extLst>
           </p:cNvPr>
@@ -2855,7 +2855,7 @@
           <p:cNvPr id="22" name="">
             <a:extLst xmlns:a="http://schemas.openxmlformats.org/drawingml/2006/main">
               <a:ext uri="{FF2B5EF4-FFF2-40B4-BE49-F238E27FC236}">
-                <a16:creationId xmlns:a16="http://schemas.microsoft.com/office/drawing/2014/main" id="{8AEB92F3-9387-45B1-A426-AFE033493304}"/>
+                <a16:creationId xmlns:a16="http://schemas.microsoft.com/office/drawing/2014/main" id="{D2728EC1-3882-4DB3-8696-CF4D1A685A61}"/>
               </a:ext>
             </a:extLst>
           </p:cNvPr>
@@ -2919,7 +2919,7 @@
           <p:cNvPr id="23" name="">
             <a:extLst xmlns:a="http://schemas.openxmlformats.org/drawingml/2006/main">
               <a:ext uri="{FF2B5EF4-FFF2-40B4-BE49-F238E27FC236}">
-                <a16:creationId xmlns:a16="http://schemas.microsoft.com/office/drawing/2014/main" id="{66776275-DC5B-4D71-A79A-BA51A6EBABA4}"/>
+                <a16:creationId xmlns:a16="http://schemas.microsoft.com/office/drawing/2014/main" id="{F3110838-9B3A-4179-9A75-13C6374BD584}"/>
               </a:ext>
             </a:extLst>
           </p:cNvPr>
@@ -2981,7 +2981,7 @@
     </p:spTree>
     <p:extLst>
       <p:ext uri="{BB962C8B-B14F-4D97-AF65-F5344CB8AC3E}">
-        <p14:creationId xmlns:p14="http://schemas.microsoft.com/office/powerpoint/2010/main" val="1927544598"/>
+        <p14:creationId xmlns:p14="http://schemas.microsoft.com/office/powerpoint/2010/main" val="1352946196"/>
       </p:ext>
     </p:extLst>
   </p:cSld>
@@ -3005,7 +3005,7 @@
           <p:cNvPr id="1" name="">
             <a:extLst xmlns:a="http://schemas.openxmlformats.org/drawingml/2006/main">
               <a:ext uri="{FF2B5EF4-FFF2-40B4-BE49-F238E27FC236}">
-                <a16:creationId xmlns:a16="http://schemas.microsoft.com/office/drawing/2014/main" id="{A87328A4-A7DB-4C87-A116-E2C54FF88535}"/>
+                <a16:creationId xmlns:a16="http://schemas.microsoft.com/office/drawing/2014/main" id="{D2FC0854-7C5E-444A-9B35-972E3004E291}"/>
               </a:ext>
             </a:extLst>
           </p:cNvPr>
@@ -3040,7 +3040,7 @@
           <p:cNvPr id="2" name="">
             <a:extLst xmlns:a="http://schemas.openxmlformats.org/drawingml/2006/main">
               <a:ext uri="{FF2B5EF4-FFF2-40B4-BE49-F238E27FC236}">
-                <a16:creationId xmlns:a16="http://schemas.microsoft.com/office/drawing/2014/main" id="{C55E3E19-501D-4C44-B91A-AF97BCC9EF1F}"/>
+                <a16:creationId xmlns:a16="http://schemas.microsoft.com/office/drawing/2014/main" id="{F3D53979-B16B-43DD-BDA5-9C88859749BB}"/>
               </a:ext>
             </a:extLst>
           </p:cNvPr>
@@ -3104,7 +3104,7 @@
           <p:cNvPr id="3" name="">
             <a:extLst xmlns:a="http://schemas.openxmlformats.org/drawingml/2006/main">
               <a:ext uri="{FF2B5EF4-FFF2-40B4-BE49-F238E27FC236}">
-                <a16:creationId xmlns:a16="http://schemas.microsoft.com/office/drawing/2014/main" id="{E79B224E-6FC3-47A3-99A6-14456025FE1E}"/>
+                <a16:creationId xmlns:a16="http://schemas.microsoft.com/office/drawing/2014/main" id="{BA0D3CC4-BBAD-4873-8F41-29E897DBB640}"/>
               </a:ext>
             </a:extLst>
           </p:cNvPr>
@@ -3168,7 +3168,7 @@
           <p:cNvPr id="4" name="">
             <a:extLst xmlns:a="http://schemas.openxmlformats.org/drawingml/2006/main">
               <a:ext uri="{FF2B5EF4-FFF2-40B4-BE49-F238E27FC236}">
-                <a16:creationId xmlns:a16="http://schemas.microsoft.com/office/drawing/2014/main" id="{E2C62D0A-DC42-4B6E-9931-76F42AFC7347}"/>
+                <a16:creationId xmlns:a16="http://schemas.microsoft.com/office/drawing/2014/main" id="{1CC98917-8C31-4F6A-9816-AD1B36E98B82}"/>
               </a:ext>
             </a:extLst>
           </p:cNvPr>
@@ -3232,7 +3232,7 @@
           <p:cNvPr id="5" name="">
             <a:extLst xmlns:a="http://schemas.openxmlformats.org/drawingml/2006/main">
               <a:ext uri="{FF2B5EF4-FFF2-40B4-BE49-F238E27FC236}">
-                <a16:creationId xmlns:a16="http://schemas.microsoft.com/office/drawing/2014/main" id="{7D67366A-5577-49E7-A89A-F22867D2E364}"/>
+                <a16:creationId xmlns:a16="http://schemas.microsoft.com/office/drawing/2014/main" id="{28F9B708-D1D5-4E15-8CFC-A345B8955DFC}"/>
               </a:ext>
             </a:extLst>
           </p:cNvPr>
@@ -3267,7 +3267,7 @@
           <p:cNvPr id="6" name="">
             <a:extLst xmlns:a="http://schemas.openxmlformats.org/drawingml/2006/main">
               <a:ext uri="{FF2B5EF4-FFF2-40B4-BE49-F238E27FC236}">
-                <a16:creationId xmlns:a16="http://schemas.microsoft.com/office/drawing/2014/main" id="{BF0484AF-19DA-43A4-A553-3152F782F0D8}"/>
+                <a16:creationId xmlns:a16="http://schemas.microsoft.com/office/drawing/2014/main" id="{CE17A26C-E910-4D39-B725-2653178CCEAA}"/>
               </a:ext>
             </a:extLst>
           </p:cNvPr>
@@ -3331,7 +3331,7 @@
           <p:cNvPr id="7" name="">
             <a:extLst xmlns:a="http://schemas.openxmlformats.org/drawingml/2006/main">
               <a:ext uri="{FF2B5EF4-FFF2-40B4-BE49-F238E27FC236}">
-                <a16:creationId xmlns:a16="http://schemas.microsoft.com/office/drawing/2014/main" id="{7E24DEF8-F2A7-412A-A794-86AED7AD7F47}"/>
+                <a16:creationId xmlns:a16="http://schemas.microsoft.com/office/drawing/2014/main" id="{3942E2C8-EC18-42EA-AABB-0BD46A821007}"/>
               </a:ext>
             </a:extLst>
           </p:cNvPr>
@@ -3395,7 +3395,7 @@
           <p:cNvPr id="8" name="">
             <a:extLst xmlns:a="http://schemas.openxmlformats.org/drawingml/2006/main">
               <a:ext uri="{FF2B5EF4-FFF2-40B4-BE49-F238E27FC236}">
-                <a16:creationId xmlns:a16="http://schemas.microsoft.com/office/drawing/2014/main" id="{8CA6A437-8A3E-44AE-855B-88B5B302C91E}"/>
+                <a16:creationId xmlns:a16="http://schemas.microsoft.com/office/drawing/2014/main" id="{7DB2E908-3BED-4325-8621-0DEC1E859460}"/>
               </a:ext>
             </a:extLst>
           </p:cNvPr>
@@ -3459,7 +3459,7 @@
           <p:cNvPr id="9" name="">
             <a:extLst xmlns:a="http://schemas.openxmlformats.org/drawingml/2006/main">
               <a:ext uri="{FF2B5EF4-FFF2-40B4-BE49-F238E27FC236}">
-                <a16:creationId xmlns:a16="http://schemas.microsoft.com/office/drawing/2014/main" id="{D5E255A0-6466-4E83-8C45-D6E79D59EF2D}"/>
+                <a16:creationId xmlns:a16="http://schemas.microsoft.com/office/drawing/2014/main" id="{FC0D90AB-D939-451E-AC4B-83E5A857CC14}"/>
               </a:ext>
             </a:extLst>
           </p:cNvPr>
@@ -3523,7 +3523,7 @@
           <p:cNvPr id="10" name="">
             <a:extLst xmlns:a="http://schemas.openxmlformats.org/drawingml/2006/main">
               <a:ext uri="{FF2B5EF4-FFF2-40B4-BE49-F238E27FC236}">
-                <a16:creationId xmlns:a16="http://schemas.microsoft.com/office/drawing/2014/main" id="{7D8D864E-F102-4156-8E9E-BA9D6BB9F1D8}"/>
+                <a16:creationId xmlns:a16="http://schemas.microsoft.com/office/drawing/2014/main" id="{95B3D6AD-37AA-4841-87A3-8FE9213AC9D7}"/>
               </a:ext>
             </a:extLst>
           </p:cNvPr>
@@ -3587,7 +3587,7 @@
           <p:cNvPr id="11" name="">
             <a:extLst xmlns:a="http://schemas.openxmlformats.org/drawingml/2006/main">
               <a:ext uri="{FF2B5EF4-FFF2-40B4-BE49-F238E27FC236}">
-                <a16:creationId xmlns:a16="http://schemas.microsoft.com/office/drawing/2014/main" id="{3C84237A-CB5E-4031-9412-6A143B6579B7}"/>
+                <a16:creationId xmlns:a16="http://schemas.microsoft.com/office/drawing/2014/main" id="{91B74059-FC80-4883-A3EC-C2A958CD324F}"/>
               </a:ext>
             </a:extLst>
           </p:cNvPr>
@@ -3651,7 +3651,7 @@
           <p:cNvPr id="12" name="">
             <a:extLst xmlns:a="http://schemas.openxmlformats.org/drawingml/2006/main">
               <a:ext uri="{FF2B5EF4-FFF2-40B4-BE49-F238E27FC236}">
-                <a16:creationId xmlns:a16="http://schemas.microsoft.com/office/drawing/2014/main" id="{9DACE4F7-B899-40A2-A4DC-A734D0698F3C}"/>
+                <a16:creationId xmlns:a16="http://schemas.microsoft.com/office/drawing/2014/main" id="{2EC7840C-3C45-4F68-9115-1FE6254678E0}"/>
               </a:ext>
             </a:extLst>
           </p:cNvPr>
@@ -3715,7 +3715,7 @@
           <p:cNvPr id="13" name="">
             <a:extLst xmlns:a="http://schemas.openxmlformats.org/drawingml/2006/main">
               <a:ext uri="{FF2B5EF4-FFF2-40B4-BE49-F238E27FC236}">
-                <a16:creationId xmlns:a16="http://schemas.microsoft.com/office/drawing/2014/main" id="{5BF06863-0045-4E37-A4F0-3B2B906C2E4F}"/>
+                <a16:creationId xmlns:a16="http://schemas.microsoft.com/office/drawing/2014/main" id="{5108D2F7-0A63-4F36-807C-0841EAD730ED}"/>
               </a:ext>
             </a:extLst>
           </p:cNvPr>
@@ -3779,7 +3779,7 @@
           <p:cNvPr id="14" name="">
             <a:extLst xmlns:a="http://schemas.openxmlformats.org/drawingml/2006/main">
               <a:ext uri="{FF2B5EF4-FFF2-40B4-BE49-F238E27FC236}">
-                <a16:creationId xmlns:a16="http://schemas.microsoft.com/office/drawing/2014/main" id="{75453681-CC26-4EB5-9BF1-C93D5632B3AD}"/>
+                <a16:creationId xmlns:a16="http://schemas.microsoft.com/office/drawing/2014/main" id="{2C991AF5-9D20-4825-8099-86B5E0235E3B}"/>
               </a:ext>
             </a:extLst>
           </p:cNvPr>
@@ -3843,7 +3843,7 @@
           <p:cNvPr id="15" name="">
             <a:extLst xmlns:a="http://schemas.openxmlformats.org/drawingml/2006/main">
               <a:ext uri="{FF2B5EF4-FFF2-40B4-BE49-F238E27FC236}">
-                <a16:creationId xmlns:a16="http://schemas.microsoft.com/office/drawing/2014/main" id="{A8D59FEB-523F-4F84-921E-616189607ED5}"/>
+                <a16:creationId xmlns:a16="http://schemas.microsoft.com/office/drawing/2014/main" id="{63F91BF9-ED94-43DD-8B1D-3E3388B31B66}"/>
               </a:ext>
             </a:extLst>
           </p:cNvPr>
@@ -3907,7 +3907,7 @@
           <p:cNvPr id="16" name="">
             <a:extLst xmlns:a="http://schemas.openxmlformats.org/drawingml/2006/main">
               <a:ext uri="{FF2B5EF4-FFF2-40B4-BE49-F238E27FC236}">
-                <a16:creationId xmlns:a16="http://schemas.microsoft.com/office/drawing/2014/main" id="{68CAD5B9-7483-4838-8A48-E5E1C4EF9206}"/>
+                <a16:creationId xmlns:a16="http://schemas.microsoft.com/office/drawing/2014/main" id="{8DD816CD-2C63-488F-9AF4-4EFBBC68FCDF}"/>
               </a:ext>
             </a:extLst>
           </p:cNvPr>
@@ -3942,7 +3942,7 @@
           <p:cNvPr id="17" name="">
             <a:extLst xmlns:a="http://schemas.openxmlformats.org/drawingml/2006/main">
               <a:ext uri="{FF2B5EF4-FFF2-40B4-BE49-F238E27FC236}">
-                <a16:creationId xmlns:a16="http://schemas.microsoft.com/office/drawing/2014/main" id="{6A570A4F-A8C7-47B5-A86E-40AE81DB827F}"/>
+                <a16:creationId xmlns:a16="http://schemas.microsoft.com/office/drawing/2014/main" id="{B54EA08D-7C8C-4B7B-96CC-5025AC93318D}"/>
               </a:ext>
             </a:extLst>
           </p:cNvPr>
@@ -4006,7 +4006,7 @@
           <p:cNvPr id="18" name="">
             <a:extLst xmlns:a="http://schemas.openxmlformats.org/drawingml/2006/main">
               <a:ext uri="{FF2B5EF4-FFF2-40B4-BE49-F238E27FC236}">
-                <a16:creationId xmlns:a16="http://schemas.microsoft.com/office/drawing/2014/main" id="{E128810A-B494-42C4-9FBC-7653D0C45F1A}"/>
+                <a16:creationId xmlns:a16="http://schemas.microsoft.com/office/drawing/2014/main" id="{F68B8ED1-DEE4-4E53-B8D7-5A60325A8044}"/>
               </a:ext>
             </a:extLst>
           </p:cNvPr>
@@ -4041,7 +4041,7 @@
           <p:cNvPr id="19" name="">
             <a:extLst xmlns:a="http://schemas.openxmlformats.org/drawingml/2006/main">
               <a:ext uri="{FF2B5EF4-FFF2-40B4-BE49-F238E27FC236}">
-                <a16:creationId xmlns:a16="http://schemas.microsoft.com/office/drawing/2014/main" id="{3CC03D3C-F435-4814-B354-481E96289B0C}"/>
+                <a16:creationId xmlns:a16="http://schemas.microsoft.com/office/drawing/2014/main" id="{7EA60A3F-6B38-41EA-B9ED-4CFB9A812E80}"/>
               </a:ext>
             </a:extLst>
           </p:cNvPr>
@@ -4105,7 +4105,7 @@
           <p:cNvPr id="20" name="">
             <a:extLst xmlns:a="http://schemas.openxmlformats.org/drawingml/2006/main">
               <a:ext uri="{FF2B5EF4-FFF2-40B4-BE49-F238E27FC236}">
-                <a16:creationId xmlns:a16="http://schemas.microsoft.com/office/drawing/2014/main" id="{5150E9F4-12C2-49FD-9992-0DCFAA969B17}"/>
+                <a16:creationId xmlns:a16="http://schemas.microsoft.com/office/drawing/2014/main" id="{42B1FEA3-2722-4915-B7B8-DAB840E3904C}"/>
               </a:ext>
             </a:extLst>
           </p:cNvPr>
@@ -4140,7 +4140,7 @@
           <p:cNvPr id="21" name="">
             <a:extLst xmlns:a="http://schemas.openxmlformats.org/drawingml/2006/main">
               <a:ext uri="{FF2B5EF4-FFF2-40B4-BE49-F238E27FC236}">
-                <a16:creationId xmlns:a16="http://schemas.microsoft.com/office/drawing/2014/main" id="{9B108D8B-960E-49CC-8371-A8EEF91A31DF}"/>
+                <a16:creationId xmlns:a16="http://schemas.microsoft.com/office/drawing/2014/main" id="{6E6F9B62-C2DF-41FD-82E1-4655E3298F07}"/>
               </a:ext>
             </a:extLst>
           </p:cNvPr>
@@ -4204,7 +4204,7 @@
           <p:cNvPr id="22" name="">
             <a:extLst xmlns:a="http://schemas.openxmlformats.org/drawingml/2006/main">
               <a:ext uri="{FF2B5EF4-FFF2-40B4-BE49-F238E27FC236}">
-                <a16:creationId xmlns:a16="http://schemas.microsoft.com/office/drawing/2014/main" id="{B51B5D47-855F-4196-B09F-4E9D9186139D}"/>
+                <a16:creationId xmlns:a16="http://schemas.microsoft.com/office/drawing/2014/main" id="{B4A17D8B-A34F-41AF-BFCD-D69427694935}"/>
               </a:ext>
             </a:extLst>
           </p:cNvPr>
@@ -4268,7 +4268,7 @@
           <p:cNvPr id="23" name="">
             <a:extLst xmlns:a="http://schemas.openxmlformats.org/drawingml/2006/main">
               <a:ext uri="{FF2B5EF4-FFF2-40B4-BE49-F238E27FC236}">
-                <a16:creationId xmlns:a16="http://schemas.microsoft.com/office/drawing/2014/main" id="{477745EE-2197-4E63-B44B-35ED93BAE2D2}"/>
+                <a16:creationId xmlns:a16="http://schemas.microsoft.com/office/drawing/2014/main" id="{635BAE26-FCB6-495B-AC95-43F7F2897E61}"/>
               </a:ext>
             </a:extLst>
           </p:cNvPr>
@@ -4330,7 +4330,7 @@
     </p:spTree>
     <p:extLst>
       <p:ext uri="{BB962C8B-B14F-4D97-AF65-F5344CB8AC3E}">
-        <p14:creationId xmlns:p14="http://schemas.microsoft.com/office/powerpoint/2010/main" val="816919134"/>
+        <p14:creationId xmlns:p14="http://schemas.microsoft.com/office/powerpoint/2010/main" val="588284238"/>
       </p:ext>
     </p:extLst>
   </p:cSld>
@@ -4354,7 +4354,7 @@
           <p:cNvPr id="1" name="">
             <a:extLst xmlns:a="http://schemas.openxmlformats.org/drawingml/2006/main">
               <a:ext uri="{FF2B5EF4-FFF2-40B4-BE49-F238E27FC236}">
-                <a16:creationId xmlns:a16="http://schemas.microsoft.com/office/drawing/2014/main" id="{3E1B3270-5CE6-4F5E-8B14-EA3FC236ACE1}"/>
+                <a16:creationId xmlns:a16="http://schemas.microsoft.com/office/drawing/2014/main" id="{9F14FD04-152D-449F-9741-B8D4D8645C16}"/>
               </a:ext>
             </a:extLst>
           </p:cNvPr>
@@ -4389,7 +4389,7 @@
           <p:cNvPr id="2" name="">
             <a:extLst xmlns:a="http://schemas.openxmlformats.org/drawingml/2006/main">
               <a:ext uri="{FF2B5EF4-FFF2-40B4-BE49-F238E27FC236}">
-                <a16:creationId xmlns:a16="http://schemas.microsoft.com/office/drawing/2014/main" id="{4FB0DF11-6976-4032-B508-F49388705B5B}"/>
+                <a16:creationId xmlns:a16="http://schemas.microsoft.com/office/drawing/2014/main" id="{98DE7282-34CD-4844-80A3-C442652E4CAC}"/>
               </a:ext>
             </a:extLst>
           </p:cNvPr>
@@ -4453,7 +4453,7 @@
           <p:cNvPr id="3" name="">
             <a:extLst xmlns:a="http://schemas.openxmlformats.org/drawingml/2006/main">
               <a:ext uri="{FF2B5EF4-FFF2-40B4-BE49-F238E27FC236}">
-                <a16:creationId xmlns:a16="http://schemas.microsoft.com/office/drawing/2014/main" id="{3E5BC34F-7347-4ACC-869A-D3F6A7EA5B03}"/>
+                <a16:creationId xmlns:a16="http://schemas.microsoft.com/office/drawing/2014/main" id="{1252A42C-AFF8-4D07-B71B-1573633F4E4C}"/>
               </a:ext>
             </a:extLst>
           </p:cNvPr>
@@ -4517,7 +4517,7 @@
           <p:cNvPr id="4" name="">
             <a:extLst xmlns:a="http://schemas.openxmlformats.org/drawingml/2006/main">
               <a:ext uri="{FF2B5EF4-FFF2-40B4-BE49-F238E27FC236}">
-                <a16:creationId xmlns:a16="http://schemas.microsoft.com/office/drawing/2014/main" id="{F6483DBA-DDDB-4826-8BBB-D6E7FAE25000}"/>
+                <a16:creationId xmlns:a16="http://schemas.microsoft.com/office/drawing/2014/main" id="{36C50E80-A21D-4F34-8533-FE1E9082BBD3}"/>
               </a:ext>
             </a:extLst>
           </p:cNvPr>
@@ -4581,7 +4581,7 @@
           <p:cNvPr id="5" name="">
             <a:extLst xmlns:a="http://schemas.openxmlformats.org/drawingml/2006/main">
               <a:ext uri="{FF2B5EF4-FFF2-40B4-BE49-F238E27FC236}">
-                <a16:creationId xmlns:a16="http://schemas.microsoft.com/office/drawing/2014/main" id="{5C9337E7-A3C6-4635-BB00-BB1A7A061968}"/>
+                <a16:creationId xmlns:a16="http://schemas.microsoft.com/office/drawing/2014/main" id="{2BA3F7E6-BC7A-4D1E-A1A2-6DB860A24812}"/>
               </a:ext>
             </a:extLst>
           </p:cNvPr>
@@ -4616,7 +4616,7 @@
           <p:cNvPr id="6" name="">
             <a:extLst xmlns:a="http://schemas.openxmlformats.org/drawingml/2006/main">
               <a:ext uri="{FF2B5EF4-FFF2-40B4-BE49-F238E27FC236}">
-                <a16:creationId xmlns:a16="http://schemas.microsoft.com/office/drawing/2014/main" id="{BDF7B171-7659-4B92-AC65-20A8CE70619D}"/>
+                <a16:creationId xmlns:a16="http://schemas.microsoft.com/office/drawing/2014/main" id="{7DB69924-C691-40EB-BE52-B37AB9949062}"/>
               </a:ext>
             </a:extLst>
           </p:cNvPr>
@@ -4649,7 +4649,7 @@
           <p:cNvPr id="7" name="">
             <a:extLst xmlns:a="http://schemas.openxmlformats.org/drawingml/2006/main">
               <a:ext uri="{FF2B5EF4-FFF2-40B4-BE49-F238E27FC236}">
-                <a16:creationId xmlns:a16="http://schemas.microsoft.com/office/drawing/2014/main" id="{634BA536-ACBA-4974-B6D6-7E2C01DAA0A1}"/>
+                <a16:creationId xmlns:a16="http://schemas.microsoft.com/office/drawing/2014/main" id="{A15B541A-8DB5-4F35-80B5-E0946068D4DF}"/>
               </a:ext>
             </a:extLst>
           </p:cNvPr>
@@ -4713,7 +4713,7 @@
           <p:cNvPr id="8" name="">
             <a:extLst xmlns:a="http://schemas.openxmlformats.org/drawingml/2006/main">
               <a:ext uri="{FF2B5EF4-FFF2-40B4-BE49-F238E27FC236}">
-                <a16:creationId xmlns:a16="http://schemas.microsoft.com/office/drawing/2014/main" id="{87E21699-6FCD-4CB4-8472-70144F1FC4E9}"/>
+                <a16:creationId xmlns:a16="http://schemas.microsoft.com/office/drawing/2014/main" id="{DDF079D8-788E-496F-99B5-AA92020F2A66}"/>
               </a:ext>
             </a:extLst>
           </p:cNvPr>
@@ -4777,7 +4777,7 @@
           <p:cNvPr id="9" name="">
             <a:extLst xmlns:a="http://schemas.openxmlformats.org/drawingml/2006/main">
               <a:ext uri="{FF2B5EF4-FFF2-40B4-BE49-F238E27FC236}">
-                <a16:creationId xmlns:a16="http://schemas.microsoft.com/office/drawing/2014/main" id="{29AC667B-5C78-4D77-816A-444182C5A3DB}"/>
+                <a16:creationId xmlns:a16="http://schemas.microsoft.com/office/drawing/2014/main" id="{111D2C62-2B73-48C1-8D11-00E48DC2FF2A}"/>
               </a:ext>
             </a:extLst>
           </p:cNvPr>
@@ -4810,7 +4810,7 @@
           <p:cNvPr id="10" name="">
             <a:extLst xmlns:a="http://schemas.openxmlformats.org/drawingml/2006/main">
               <a:ext uri="{FF2B5EF4-FFF2-40B4-BE49-F238E27FC236}">
-                <a16:creationId xmlns:a16="http://schemas.microsoft.com/office/drawing/2014/main" id="{06C5956C-4071-424C-A8A6-163EA5ED4C73}"/>
+                <a16:creationId xmlns:a16="http://schemas.microsoft.com/office/drawing/2014/main" id="{5B007EAF-8285-45BB-9791-784AAA7B7DE7}"/>
               </a:ext>
             </a:extLst>
           </p:cNvPr>
@@ -4874,7 +4874,7 @@
           <p:cNvPr id="11" name="">
             <a:extLst xmlns:a="http://schemas.openxmlformats.org/drawingml/2006/main">
               <a:ext uri="{FF2B5EF4-FFF2-40B4-BE49-F238E27FC236}">
-                <a16:creationId xmlns:a16="http://schemas.microsoft.com/office/drawing/2014/main" id="{348D9A79-0476-42F8-BA78-0D2D0D2DF2D4}"/>
+                <a16:creationId xmlns:a16="http://schemas.microsoft.com/office/drawing/2014/main" id="{8B623A15-55B6-41BB-B7F4-7E848B504863}"/>
               </a:ext>
             </a:extLst>
           </p:cNvPr>
@@ -4938,7 +4938,7 @@
           <p:cNvPr id="12" name="">
             <a:extLst xmlns:a="http://schemas.openxmlformats.org/drawingml/2006/main">
               <a:ext uri="{FF2B5EF4-FFF2-40B4-BE49-F238E27FC236}">
-                <a16:creationId xmlns:a16="http://schemas.microsoft.com/office/drawing/2014/main" id="{DBDBB2C9-E240-4482-A976-CDE405FE6424}"/>
+                <a16:creationId xmlns:a16="http://schemas.microsoft.com/office/drawing/2014/main" id="{3D55ED9A-E67C-431E-AD23-857D55D1DFA3}"/>
               </a:ext>
             </a:extLst>
           </p:cNvPr>
@@ -4971,7 +4971,7 @@
           <p:cNvPr id="13" name="">
             <a:extLst xmlns:a="http://schemas.openxmlformats.org/drawingml/2006/main">
               <a:ext uri="{FF2B5EF4-FFF2-40B4-BE49-F238E27FC236}">
-                <a16:creationId xmlns:a16="http://schemas.microsoft.com/office/drawing/2014/main" id="{0BAF496C-266E-46D5-841F-A73B3C8F560A}"/>
+                <a16:creationId xmlns:a16="http://schemas.microsoft.com/office/drawing/2014/main" id="{309E5C8A-12BB-435D-9025-8FF40D71CC16}"/>
               </a:ext>
             </a:extLst>
           </p:cNvPr>
@@ -5035,7 +5035,7 @@
           <p:cNvPr id="14" name="">
             <a:extLst xmlns:a="http://schemas.openxmlformats.org/drawingml/2006/main">
               <a:ext uri="{FF2B5EF4-FFF2-40B4-BE49-F238E27FC236}">
-                <a16:creationId xmlns:a16="http://schemas.microsoft.com/office/drawing/2014/main" id="{52E4E93D-076F-409F-9F82-F7CA8525843C}"/>
+                <a16:creationId xmlns:a16="http://schemas.microsoft.com/office/drawing/2014/main" id="{D0614AF5-0C71-49B1-B8F3-1BCCD7B8C1BB}"/>
               </a:ext>
             </a:extLst>
           </p:cNvPr>
@@ -5099,7 +5099,7 @@
           <p:cNvPr id="15" name="">
             <a:extLst xmlns:a="http://schemas.openxmlformats.org/drawingml/2006/main">
               <a:ext uri="{FF2B5EF4-FFF2-40B4-BE49-F238E27FC236}">
-                <a16:creationId xmlns:a16="http://schemas.microsoft.com/office/drawing/2014/main" id="{7B1CB3FD-6196-4BED-9269-2DB196714827}"/>
+                <a16:creationId xmlns:a16="http://schemas.microsoft.com/office/drawing/2014/main" id="{5FE98553-45C0-4C48-8B65-7FF3517441E9}"/>
               </a:ext>
             </a:extLst>
           </p:cNvPr>
@@ -5132,7 +5132,7 @@
           <p:cNvPr id="16" name="">
             <a:extLst xmlns:a="http://schemas.openxmlformats.org/drawingml/2006/main">
               <a:ext uri="{FF2B5EF4-FFF2-40B4-BE49-F238E27FC236}">
-                <a16:creationId xmlns:a16="http://schemas.microsoft.com/office/drawing/2014/main" id="{D37A9547-F922-4DC3-87FA-7FFB65DF58BB}"/>
+                <a16:creationId xmlns:a16="http://schemas.microsoft.com/office/drawing/2014/main" id="{FA30519F-3B41-457D-AC48-B7910EA80652}"/>
               </a:ext>
             </a:extLst>
           </p:cNvPr>
@@ -5196,7 +5196,7 @@
           <p:cNvPr id="17" name="">
             <a:extLst xmlns:a="http://schemas.openxmlformats.org/drawingml/2006/main">
               <a:ext uri="{FF2B5EF4-FFF2-40B4-BE49-F238E27FC236}">
-                <a16:creationId xmlns:a16="http://schemas.microsoft.com/office/drawing/2014/main" id="{66722498-565B-453E-8CC6-ED12EB5FC382}"/>
+                <a16:creationId xmlns:a16="http://schemas.microsoft.com/office/drawing/2014/main" id="{4ED6580D-66AE-46FC-ABF8-FD8CD8BCC314}"/>
               </a:ext>
             </a:extLst>
           </p:cNvPr>
@@ -5260,7 +5260,7 @@
           <p:cNvPr id="18" name="">
             <a:extLst xmlns:a="http://schemas.openxmlformats.org/drawingml/2006/main">
               <a:ext uri="{FF2B5EF4-FFF2-40B4-BE49-F238E27FC236}">
-                <a16:creationId xmlns:a16="http://schemas.microsoft.com/office/drawing/2014/main" id="{19D58C45-E415-47CE-9244-1981B825F682}"/>
+                <a16:creationId xmlns:a16="http://schemas.microsoft.com/office/drawing/2014/main" id="{A57D3D6A-5AA2-42BF-B398-52E447DCD3E1}"/>
               </a:ext>
             </a:extLst>
           </p:cNvPr>
@@ -5322,7 +5322,7 @@
     </p:spTree>
     <p:extLst>
       <p:ext uri="{BB962C8B-B14F-4D97-AF65-F5344CB8AC3E}">
-        <p14:creationId xmlns:p14="http://schemas.microsoft.com/office/powerpoint/2010/main" val="1310296397"/>
+        <p14:creationId xmlns:p14="http://schemas.microsoft.com/office/powerpoint/2010/main" val="1334240483"/>
       </p:ext>
     </p:extLst>
   </p:cSld>
@@ -5346,7 +5346,7 @@
           <p:cNvPr id="1" name="">
             <a:extLst xmlns:a="http://schemas.openxmlformats.org/drawingml/2006/main">
               <a:ext uri="{FF2B5EF4-FFF2-40B4-BE49-F238E27FC236}">
-                <a16:creationId xmlns:a16="http://schemas.microsoft.com/office/drawing/2014/main" id="{A5D949AA-888E-4A1C-A9C4-9D94CC7C5602}"/>
+                <a16:creationId xmlns:a16="http://schemas.microsoft.com/office/drawing/2014/main" id="{B92EA050-7D78-405B-A12B-7A89A093613F}"/>
               </a:ext>
             </a:extLst>
           </p:cNvPr>
@@ -5381,7 +5381,7 @@
           <p:cNvPr id="2" name="">
             <a:extLst xmlns:a="http://schemas.openxmlformats.org/drawingml/2006/main">
               <a:ext uri="{FF2B5EF4-FFF2-40B4-BE49-F238E27FC236}">
-                <a16:creationId xmlns:a16="http://schemas.microsoft.com/office/drawing/2014/main" id="{E7DED23E-A767-4A04-A24B-D2F615FAF97C}"/>
+                <a16:creationId xmlns:a16="http://schemas.microsoft.com/office/drawing/2014/main" id="{FC5664EF-D044-4EF5-AD71-7F2AC0BC0C6E}"/>
               </a:ext>
             </a:extLst>
           </p:cNvPr>
@@ -5445,7 +5445,7 @@
           <p:cNvPr id="3" name="">
             <a:extLst xmlns:a="http://schemas.openxmlformats.org/drawingml/2006/main">
               <a:ext uri="{FF2B5EF4-FFF2-40B4-BE49-F238E27FC236}">
-                <a16:creationId xmlns:a16="http://schemas.microsoft.com/office/drawing/2014/main" id="{82617F11-91E6-423C-90C1-AB9265002D79}"/>
+                <a16:creationId xmlns:a16="http://schemas.microsoft.com/office/drawing/2014/main" id="{A32BE532-5142-41A7-BA3D-51A9963A5FEB}"/>
               </a:ext>
             </a:extLst>
           </p:cNvPr>
@@ -5509,7 +5509,7 @@
           <p:cNvPr id="4" name="">
             <a:extLst xmlns:a="http://schemas.openxmlformats.org/drawingml/2006/main">
               <a:ext uri="{FF2B5EF4-FFF2-40B4-BE49-F238E27FC236}">
-                <a16:creationId xmlns:a16="http://schemas.microsoft.com/office/drawing/2014/main" id="{035462D8-6BCA-43AE-9FAF-57A98F7143A0}"/>
+                <a16:creationId xmlns:a16="http://schemas.microsoft.com/office/drawing/2014/main" id="{3A03EB42-6FB3-4826-8DD7-B23269BACC91}"/>
               </a:ext>
             </a:extLst>
           </p:cNvPr>
@@ -5573,7 +5573,7 @@
           <p:cNvPr id="5" name="">
             <a:extLst xmlns:a="http://schemas.openxmlformats.org/drawingml/2006/main">
               <a:ext uri="{FF2B5EF4-FFF2-40B4-BE49-F238E27FC236}">
-                <a16:creationId xmlns:a16="http://schemas.microsoft.com/office/drawing/2014/main" id="{E004BF4C-5247-47A1-8134-7C9A4C32AFD5}"/>
+                <a16:creationId xmlns:a16="http://schemas.microsoft.com/office/drawing/2014/main" id="{3F92E42A-B146-4525-872C-14D56371A236}"/>
               </a:ext>
             </a:extLst>
           </p:cNvPr>
@@ -5608,7 +5608,7 @@
           <p:cNvPr id="6" name="">
             <a:extLst xmlns:a="http://schemas.openxmlformats.org/drawingml/2006/main">
               <a:ext uri="{FF2B5EF4-FFF2-40B4-BE49-F238E27FC236}">
-                <a16:creationId xmlns:a16="http://schemas.microsoft.com/office/drawing/2014/main" id="{1B60932C-4033-4006-905F-A99A66A16651}"/>
+                <a16:creationId xmlns:a16="http://schemas.microsoft.com/office/drawing/2014/main" id="{817CDB7C-E153-4EFB-89DA-AA7F2FF04EE5}"/>
               </a:ext>
             </a:extLst>
           </p:cNvPr>
@@ -5672,7 +5672,7 @@
           <p:cNvPr id="7" name="">
             <a:extLst xmlns:a="http://schemas.openxmlformats.org/drawingml/2006/main">
               <a:ext uri="{FF2B5EF4-FFF2-40B4-BE49-F238E27FC236}">
-                <a16:creationId xmlns:a16="http://schemas.microsoft.com/office/drawing/2014/main" id="{AF37FFDE-BAFE-488C-A634-DB4F440C3B51}"/>
+                <a16:creationId xmlns:a16="http://schemas.microsoft.com/office/drawing/2014/main" id="{9B42155F-E895-4295-B2B3-F954582E7B7E}"/>
               </a:ext>
             </a:extLst>
           </p:cNvPr>
@@ -5736,7 +5736,7 @@
           <p:cNvPr id="8" name="">
             <a:extLst xmlns:a="http://schemas.openxmlformats.org/drawingml/2006/main">
               <a:ext uri="{FF2B5EF4-FFF2-40B4-BE49-F238E27FC236}">
-                <a16:creationId xmlns:a16="http://schemas.microsoft.com/office/drawing/2014/main" id="{64B15D02-C543-4444-AE86-AB2EFFB588E3}"/>
+                <a16:creationId xmlns:a16="http://schemas.microsoft.com/office/drawing/2014/main" id="{1F3D1495-B792-4F64-843C-3149789B4683}"/>
               </a:ext>
             </a:extLst>
           </p:cNvPr>
@@ -5800,7 +5800,7 @@
           <p:cNvPr id="9" name="">
             <a:extLst xmlns:a="http://schemas.openxmlformats.org/drawingml/2006/main">
               <a:ext uri="{FF2B5EF4-FFF2-40B4-BE49-F238E27FC236}">
-                <a16:creationId xmlns:a16="http://schemas.microsoft.com/office/drawing/2014/main" id="{141CEBC4-5E98-4532-B6E1-013891169028}"/>
+                <a16:creationId xmlns:a16="http://schemas.microsoft.com/office/drawing/2014/main" id="{B9003C2F-B7A8-4E90-A102-BDCA5E916E8E}"/>
               </a:ext>
             </a:extLst>
           </p:cNvPr>
@@ -5864,7 +5864,7 @@
           <p:cNvPr id="10" name="">
             <a:extLst xmlns:a="http://schemas.openxmlformats.org/drawingml/2006/main">
               <a:ext uri="{FF2B5EF4-FFF2-40B4-BE49-F238E27FC236}">
-                <a16:creationId xmlns:a16="http://schemas.microsoft.com/office/drawing/2014/main" id="{53DDCCC3-2922-4069-9909-48A0FE47D491}"/>
+                <a16:creationId xmlns:a16="http://schemas.microsoft.com/office/drawing/2014/main" id="{407E67D3-3D26-4FC9-9236-C565E410C83F}"/>
               </a:ext>
             </a:extLst>
           </p:cNvPr>
@@ -5928,7 +5928,7 @@
           <p:cNvPr id="11" name="">
             <a:extLst xmlns:a="http://schemas.openxmlformats.org/drawingml/2006/main">
               <a:ext uri="{FF2B5EF4-FFF2-40B4-BE49-F238E27FC236}">
-                <a16:creationId xmlns:a16="http://schemas.microsoft.com/office/drawing/2014/main" id="{23269FC7-B3CA-4CB7-943B-1E8E5C6E5717}"/>
+                <a16:creationId xmlns:a16="http://schemas.microsoft.com/office/drawing/2014/main" id="{5E1C3811-3919-41C4-AA30-07A69A8465CB}"/>
               </a:ext>
             </a:extLst>
           </p:cNvPr>
@@ -5992,7 +5992,7 @@
           <p:cNvPr id="12" name="">
             <a:extLst xmlns:a="http://schemas.openxmlformats.org/drawingml/2006/main">
               <a:ext uri="{FF2B5EF4-FFF2-40B4-BE49-F238E27FC236}">
-                <a16:creationId xmlns:a16="http://schemas.microsoft.com/office/drawing/2014/main" id="{BDA049CA-FE82-4B52-ACA9-896B86AAA535}"/>
+                <a16:creationId xmlns:a16="http://schemas.microsoft.com/office/drawing/2014/main" id="{4443BA91-1D3C-4702-A10F-D00B81D4D347}"/>
               </a:ext>
             </a:extLst>
           </p:cNvPr>
@@ -6056,7 +6056,7 @@
           <p:cNvPr id="13" name="">
             <a:extLst xmlns:a="http://schemas.openxmlformats.org/drawingml/2006/main">
               <a:ext uri="{FF2B5EF4-FFF2-40B4-BE49-F238E27FC236}">
-                <a16:creationId xmlns:a16="http://schemas.microsoft.com/office/drawing/2014/main" id="{48F989F6-A497-4973-8363-41C6B37DD049}"/>
+                <a16:creationId xmlns:a16="http://schemas.microsoft.com/office/drawing/2014/main" id="{79B1404F-75F2-4CCF-AD13-CB5367F774EA}"/>
               </a:ext>
             </a:extLst>
           </p:cNvPr>
@@ -6120,7 +6120,7 @@
           <p:cNvPr id="14" name="">
             <a:extLst xmlns:a="http://schemas.openxmlformats.org/drawingml/2006/main">
               <a:ext uri="{FF2B5EF4-FFF2-40B4-BE49-F238E27FC236}">
-                <a16:creationId xmlns:a16="http://schemas.microsoft.com/office/drawing/2014/main" id="{A7A06959-260A-4974-98B9-ADCDB9DEA631}"/>
+                <a16:creationId xmlns:a16="http://schemas.microsoft.com/office/drawing/2014/main" id="{39752A5E-A57E-4D74-9FA2-3957F7937A23}"/>
               </a:ext>
             </a:extLst>
           </p:cNvPr>
@@ -6153,7 +6153,7 @@
           <p:cNvPr id="15" name="">
             <a:extLst xmlns:a="http://schemas.openxmlformats.org/drawingml/2006/main">
               <a:ext uri="{FF2B5EF4-FFF2-40B4-BE49-F238E27FC236}">
-                <a16:creationId xmlns:a16="http://schemas.microsoft.com/office/drawing/2014/main" id="{B8D692F4-5F91-49A0-92B0-12354D8D31CE}"/>
+                <a16:creationId xmlns:a16="http://schemas.microsoft.com/office/drawing/2014/main" id="{910A6E36-EE47-44DE-B396-0D6509DFD393}"/>
               </a:ext>
             </a:extLst>
           </p:cNvPr>
@@ -6217,7 +6217,7 @@
           <p:cNvPr id="16" name="">
             <a:extLst xmlns:a="http://schemas.openxmlformats.org/drawingml/2006/main">
               <a:ext uri="{FF2B5EF4-FFF2-40B4-BE49-F238E27FC236}">
-                <a16:creationId xmlns:a16="http://schemas.microsoft.com/office/drawing/2014/main" id="{C2DA0A19-DA8D-437F-A6C2-F18667021F83}"/>
+                <a16:creationId xmlns:a16="http://schemas.microsoft.com/office/drawing/2014/main" id="{2F975C8E-C87B-4121-83AA-56B57944C676}"/>
               </a:ext>
             </a:extLst>
           </p:cNvPr>
@@ -6281,7 +6281,7 @@
           <p:cNvPr id="17" name="">
             <a:extLst xmlns:a="http://schemas.openxmlformats.org/drawingml/2006/main">
               <a:ext uri="{FF2B5EF4-FFF2-40B4-BE49-F238E27FC236}">
-                <a16:creationId xmlns:a16="http://schemas.microsoft.com/office/drawing/2014/main" id="{AF8490DC-22B8-4663-803F-B7F5621091E2}"/>
+                <a16:creationId xmlns:a16="http://schemas.microsoft.com/office/drawing/2014/main" id="{DF79CCA8-E19C-4B11-8BDD-E477CC255D2C}"/>
               </a:ext>
             </a:extLst>
           </p:cNvPr>
@@ -6314,7 +6314,7 @@
           <p:cNvPr id="18" name="">
             <a:extLst xmlns:a="http://schemas.openxmlformats.org/drawingml/2006/main">
               <a:ext uri="{FF2B5EF4-FFF2-40B4-BE49-F238E27FC236}">
-                <a16:creationId xmlns:a16="http://schemas.microsoft.com/office/drawing/2014/main" id="{619C723C-2098-4AC0-93E9-04BD51DBD005}"/>
+                <a16:creationId xmlns:a16="http://schemas.microsoft.com/office/drawing/2014/main" id="{04339B7D-BE1B-4A0E-BB7E-DAF553EE4BDD}"/>
               </a:ext>
             </a:extLst>
           </p:cNvPr>
@@ -6378,7 +6378,7 @@
           <p:cNvPr id="19" name="">
             <a:extLst xmlns:a="http://schemas.openxmlformats.org/drawingml/2006/main">
               <a:ext uri="{FF2B5EF4-FFF2-40B4-BE49-F238E27FC236}">
-                <a16:creationId xmlns:a16="http://schemas.microsoft.com/office/drawing/2014/main" id="{8D57331B-F7F3-4C3C-A8E1-DBA689C0E448}"/>
+                <a16:creationId xmlns:a16="http://schemas.microsoft.com/office/drawing/2014/main" id="{512E18B5-8D66-46BD-AF53-42CED5E6658B}"/>
               </a:ext>
             </a:extLst>
           </p:cNvPr>
@@ -6442,7 +6442,7 @@
           <p:cNvPr id="20" name="">
             <a:extLst xmlns:a="http://schemas.openxmlformats.org/drawingml/2006/main">
               <a:ext uri="{FF2B5EF4-FFF2-40B4-BE49-F238E27FC236}">
-                <a16:creationId xmlns:a16="http://schemas.microsoft.com/office/drawing/2014/main" id="{9C5CFCF4-A083-4F7A-9002-6DFD911B2FA1}"/>
+                <a16:creationId xmlns:a16="http://schemas.microsoft.com/office/drawing/2014/main" id="{E338F188-3D14-4D32-B70F-CAA6F0007E2D}"/>
               </a:ext>
             </a:extLst>
           </p:cNvPr>
@@ -6475,7 +6475,7 @@
           <p:cNvPr id="21" name="">
             <a:extLst xmlns:a="http://schemas.openxmlformats.org/drawingml/2006/main">
               <a:ext uri="{FF2B5EF4-FFF2-40B4-BE49-F238E27FC236}">
-                <a16:creationId xmlns:a16="http://schemas.microsoft.com/office/drawing/2014/main" id="{64063D72-13D2-4AFD-B46E-2C4BEDE8CD3C}"/>
+                <a16:creationId xmlns:a16="http://schemas.microsoft.com/office/drawing/2014/main" id="{8A85BD76-6419-4CE8-BE13-26E0FE261A8D}"/>
               </a:ext>
             </a:extLst>
           </p:cNvPr>
@@ -6539,7 +6539,7 @@
           <p:cNvPr id="22" name="">
             <a:extLst xmlns:a="http://schemas.openxmlformats.org/drawingml/2006/main">
               <a:ext uri="{FF2B5EF4-FFF2-40B4-BE49-F238E27FC236}">
-                <a16:creationId xmlns:a16="http://schemas.microsoft.com/office/drawing/2014/main" id="{6A6886DE-7709-40F5-B07D-36C0C6A0C4C0}"/>
+                <a16:creationId xmlns:a16="http://schemas.microsoft.com/office/drawing/2014/main" id="{B52E4EEC-A4B6-4237-8881-1349BC4DC312}"/>
               </a:ext>
             </a:extLst>
           </p:cNvPr>
@@ -6603,7 +6603,7 @@
           <p:cNvPr id="23" name="">
             <a:extLst xmlns:a="http://schemas.openxmlformats.org/drawingml/2006/main">
               <a:ext uri="{FF2B5EF4-FFF2-40B4-BE49-F238E27FC236}">
-                <a16:creationId xmlns:a16="http://schemas.microsoft.com/office/drawing/2014/main" id="{17977BF4-C3D1-4F05-8B05-19C28EE96F8C}"/>
+                <a16:creationId xmlns:a16="http://schemas.microsoft.com/office/drawing/2014/main" id="{6F5E8318-106A-4B84-B4F7-0121B6D429F0}"/>
               </a:ext>
             </a:extLst>
           </p:cNvPr>
@@ -6636,7 +6636,7 @@
           <p:cNvPr id="24" name="">
             <a:extLst xmlns:a="http://schemas.openxmlformats.org/drawingml/2006/main">
               <a:ext uri="{FF2B5EF4-FFF2-40B4-BE49-F238E27FC236}">
-                <a16:creationId xmlns:a16="http://schemas.microsoft.com/office/drawing/2014/main" id="{82147E74-C722-4F7E-985D-0661AA05E08E}"/>
+                <a16:creationId xmlns:a16="http://schemas.microsoft.com/office/drawing/2014/main" id="{1C0A7D34-7A30-4848-B307-5FF2ABF05D19}"/>
               </a:ext>
             </a:extLst>
           </p:cNvPr>
@@ -6700,7 +6700,7 @@
           <p:cNvPr id="25" name="">
             <a:extLst xmlns:a="http://schemas.openxmlformats.org/drawingml/2006/main">
               <a:ext uri="{FF2B5EF4-FFF2-40B4-BE49-F238E27FC236}">
-                <a16:creationId xmlns:a16="http://schemas.microsoft.com/office/drawing/2014/main" id="{5E8D604F-AC69-466C-99D5-811938F01D91}"/>
+                <a16:creationId xmlns:a16="http://schemas.microsoft.com/office/drawing/2014/main" id="{1F93DA52-4AB7-49F6-84A5-8DF008EB96FB}"/>
               </a:ext>
             </a:extLst>
           </p:cNvPr>
@@ -6764,7 +6764,7 @@
           <p:cNvPr id="26" name="">
             <a:extLst xmlns:a="http://schemas.openxmlformats.org/drawingml/2006/main">
               <a:ext uri="{FF2B5EF4-FFF2-40B4-BE49-F238E27FC236}">
-                <a16:creationId xmlns:a16="http://schemas.microsoft.com/office/drawing/2014/main" id="{85BFED1D-D2ED-4C62-8E60-34E1226BFE2A}"/>
+                <a16:creationId xmlns:a16="http://schemas.microsoft.com/office/drawing/2014/main" id="{B618A333-0732-49E8-BC77-CF9697803D91}"/>
               </a:ext>
             </a:extLst>
           </p:cNvPr>
@@ -6828,7 +6828,7 @@
           <p:cNvPr id="27" name="">
             <a:extLst xmlns:a="http://schemas.openxmlformats.org/drawingml/2006/main">
               <a:ext uri="{FF2B5EF4-FFF2-40B4-BE49-F238E27FC236}">
-                <a16:creationId xmlns:a16="http://schemas.microsoft.com/office/drawing/2014/main" id="{04824E43-8BE2-4415-A178-E6300DA0C7E7}"/>
+                <a16:creationId xmlns:a16="http://schemas.microsoft.com/office/drawing/2014/main" id="{72C4528F-A8A1-49E6-B13F-1AD8E057ABF4}"/>
               </a:ext>
             </a:extLst>
           </p:cNvPr>
@@ -6890,7 +6890,7 @@
     </p:spTree>
     <p:extLst>
       <p:ext uri="{BB962C8B-B14F-4D97-AF65-F5344CB8AC3E}">
-        <p14:creationId xmlns:p14="http://schemas.microsoft.com/office/powerpoint/2010/main" val="126095734"/>
+        <p14:creationId xmlns:p14="http://schemas.microsoft.com/office/powerpoint/2010/main" val="1735827439"/>
       </p:ext>
     </p:extLst>
   </p:cSld>
@@ -6914,7 +6914,7 @@
           <p:cNvPr id="1" name="">
             <a:extLst xmlns:a="http://schemas.openxmlformats.org/drawingml/2006/main">
               <a:ext uri="{FF2B5EF4-FFF2-40B4-BE49-F238E27FC236}">
-                <a16:creationId xmlns:a16="http://schemas.microsoft.com/office/drawing/2014/main" id="{4DA76959-66D7-4CEE-9C19-81B9F8012320}"/>
+                <a16:creationId xmlns:a16="http://schemas.microsoft.com/office/drawing/2014/main" id="{9162734F-9380-41E5-A788-E843B5EFA3D2}"/>
               </a:ext>
             </a:extLst>
           </p:cNvPr>
@@ -6949,7 +6949,7 @@
           <p:cNvPr id="2" name="">
             <a:extLst xmlns:a="http://schemas.openxmlformats.org/drawingml/2006/main">
               <a:ext uri="{FF2B5EF4-FFF2-40B4-BE49-F238E27FC236}">
-                <a16:creationId xmlns:a16="http://schemas.microsoft.com/office/drawing/2014/main" id="{CE4FD320-C269-4D50-B5B6-34CDD9A9CF65}"/>
+                <a16:creationId xmlns:a16="http://schemas.microsoft.com/office/drawing/2014/main" id="{F4B29007-24AA-4DE6-93DB-B4EDC6076209}"/>
               </a:ext>
             </a:extLst>
           </p:cNvPr>
@@ -7013,7 +7013,7 @@
           <p:cNvPr id="3" name="">
             <a:extLst xmlns:a="http://schemas.openxmlformats.org/drawingml/2006/main">
               <a:ext uri="{FF2B5EF4-FFF2-40B4-BE49-F238E27FC236}">
-                <a16:creationId xmlns:a16="http://schemas.microsoft.com/office/drawing/2014/main" id="{B96659D8-62C2-4AD8-97B8-009D26E278C0}"/>
+                <a16:creationId xmlns:a16="http://schemas.microsoft.com/office/drawing/2014/main" id="{0229E6D1-FB86-43EB-928C-19C25FBD7246}"/>
               </a:ext>
             </a:extLst>
           </p:cNvPr>
@@ -7077,7 +7077,7 @@
           <p:cNvPr id="4" name="">
             <a:extLst xmlns:a="http://schemas.openxmlformats.org/drawingml/2006/main">
               <a:ext uri="{FF2B5EF4-FFF2-40B4-BE49-F238E27FC236}">
-                <a16:creationId xmlns:a16="http://schemas.microsoft.com/office/drawing/2014/main" id="{530FD4BB-C2E2-457C-ACB0-333289609E2A}"/>
+                <a16:creationId xmlns:a16="http://schemas.microsoft.com/office/drawing/2014/main" id="{B04441BE-DE0B-491B-A58E-C9EFC9C4B677}"/>
               </a:ext>
             </a:extLst>
           </p:cNvPr>
@@ -7141,7 +7141,7 @@
           <p:cNvPr id="5" name="">
             <a:extLst xmlns:a="http://schemas.openxmlformats.org/drawingml/2006/main">
               <a:ext uri="{FF2B5EF4-FFF2-40B4-BE49-F238E27FC236}">
-                <a16:creationId xmlns:a16="http://schemas.microsoft.com/office/drawing/2014/main" id="{B949B2A7-A5AB-46EA-ACE7-6F38E0792D19}"/>
+                <a16:creationId xmlns:a16="http://schemas.microsoft.com/office/drawing/2014/main" id="{4080FC37-D30C-4AF0-B197-9F6856868395}"/>
               </a:ext>
             </a:extLst>
           </p:cNvPr>
@@ -7176,7 +7176,7 @@
           <p:cNvPr id="6" name="">
             <a:extLst xmlns:a="http://schemas.openxmlformats.org/drawingml/2006/main">
               <a:ext uri="{FF2B5EF4-FFF2-40B4-BE49-F238E27FC236}">
-                <a16:creationId xmlns:a16="http://schemas.microsoft.com/office/drawing/2014/main" id="{234E6B34-E157-467D-BAE1-3C88A8E90994}"/>
+                <a16:creationId xmlns:a16="http://schemas.microsoft.com/office/drawing/2014/main" id="{9E824221-38CE-4D7B-8988-2184043D8471}"/>
               </a:ext>
             </a:extLst>
           </p:cNvPr>
@@ -7240,7 +7240,7 @@
           <p:cNvPr id="7" name="">
             <a:extLst xmlns:a="http://schemas.openxmlformats.org/drawingml/2006/main">
               <a:ext uri="{FF2B5EF4-FFF2-40B4-BE49-F238E27FC236}">
-                <a16:creationId xmlns:a16="http://schemas.microsoft.com/office/drawing/2014/main" id="{828C5C5B-66D2-466D-BB2B-453B89698DFC}"/>
+                <a16:creationId xmlns:a16="http://schemas.microsoft.com/office/drawing/2014/main" id="{937AC89B-BD0F-4BFA-B525-7FE0F3E34CE6}"/>
               </a:ext>
             </a:extLst>
           </p:cNvPr>
@@ -7304,7 +7304,7 @@
           <p:cNvPr id="8" name="">
             <a:extLst xmlns:a="http://schemas.openxmlformats.org/drawingml/2006/main">
               <a:ext uri="{FF2B5EF4-FFF2-40B4-BE49-F238E27FC236}">
-                <a16:creationId xmlns:a16="http://schemas.microsoft.com/office/drawing/2014/main" id="{DDCAF927-2CA0-4312-85BB-7C8C11576B90}"/>
+                <a16:creationId xmlns:a16="http://schemas.microsoft.com/office/drawing/2014/main" id="{7AE1CE1D-0E19-47F3-8511-62436B228332}"/>
               </a:ext>
             </a:extLst>
           </p:cNvPr>
@@ -7368,7 +7368,7 @@
           <p:cNvPr id="9" name="">
             <a:extLst xmlns:a="http://schemas.openxmlformats.org/drawingml/2006/main">
               <a:ext uri="{FF2B5EF4-FFF2-40B4-BE49-F238E27FC236}">
-                <a16:creationId xmlns:a16="http://schemas.microsoft.com/office/drawing/2014/main" id="{B860AD07-9E50-4D05-8526-C235E2CDC1FF}"/>
+                <a16:creationId xmlns:a16="http://schemas.microsoft.com/office/drawing/2014/main" id="{D3CE7E2D-1003-4708-A61F-294E8C78567F}"/>
               </a:ext>
             </a:extLst>
           </p:cNvPr>
@@ -7432,7 +7432,7 @@
           <p:cNvPr id="10" name="">
             <a:extLst xmlns:a="http://schemas.openxmlformats.org/drawingml/2006/main">
               <a:ext uri="{FF2B5EF4-FFF2-40B4-BE49-F238E27FC236}">
-                <a16:creationId xmlns:a16="http://schemas.microsoft.com/office/drawing/2014/main" id="{461F98E9-5D5C-489E-98D4-7A3983E8225E}"/>
+                <a16:creationId xmlns:a16="http://schemas.microsoft.com/office/drawing/2014/main" id="{74ED458C-E702-4B59-AB37-B9042D3938DC}"/>
               </a:ext>
             </a:extLst>
           </p:cNvPr>
@@ -7496,7 +7496,7 @@
           <p:cNvPr id="11" name="">
             <a:extLst xmlns:a="http://schemas.openxmlformats.org/drawingml/2006/main">
               <a:ext uri="{FF2B5EF4-FFF2-40B4-BE49-F238E27FC236}">
-                <a16:creationId xmlns:a16="http://schemas.microsoft.com/office/drawing/2014/main" id="{4D41CB0B-6AC4-4F27-8B1A-718C3629F3EE}"/>
+                <a16:creationId xmlns:a16="http://schemas.microsoft.com/office/drawing/2014/main" id="{FEB0609C-F1FB-4319-8335-8F38426DBC2B}"/>
               </a:ext>
             </a:extLst>
           </p:cNvPr>
@@ -7560,7 +7560,7 @@
           <p:cNvPr id="12" name="">
             <a:extLst xmlns:a="http://schemas.openxmlformats.org/drawingml/2006/main">
               <a:ext uri="{FF2B5EF4-FFF2-40B4-BE49-F238E27FC236}">
-                <a16:creationId xmlns:a16="http://schemas.microsoft.com/office/drawing/2014/main" id="{9FA174D8-414D-40E7-BB6D-99DA4E0845A3}"/>
+                <a16:creationId xmlns:a16="http://schemas.microsoft.com/office/drawing/2014/main" id="{847D35F3-715D-45B4-89CE-1F6D629CC540}"/>
               </a:ext>
             </a:extLst>
           </p:cNvPr>
@@ -7624,7 +7624,7 @@
           <p:cNvPr id="13" name="">
             <a:extLst xmlns:a="http://schemas.openxmlformats.org/drawingml/2006/main">
               <a:ext uri="{FF2B5EF4-FFF2-40B4-BE49-F238E27FC236}">
-                <a16:creationId xmlns:a16="http://schemas.microsoft.com/office/drawing/2014/main" id="{1722CADA-65BE-4C81-859D-D8C46DE622D5}"/>
+                <a16:creationId xmlns:a16="http://schemas.microsoft.com/office/drawing/2014/main" id="{208B4CCF-53AC-47A4-B4A8-6EC2BF2A8110}"/>
               </a:ext>
             </a:extLst>
           </p:cNvPr>
@@ -7688,7 +7688,7 @@
           <p:cNvPr id="14" name="">
             <a:extLst xmlns:a="http://schemas.openxmlformats.org/drawingml/2006/main">
               <a:ext uri="{FF2B5EF4-FFF2-40B4-BE49-F238E27FC236}">
-                <a16:creationId xmlns:a16="http://schemas.microsoft.com/office/drawing/2014/main" id="{53F84917-7DE1-467A-AA4D-9B74CB4CF632}"/>
+                <a16:creationId xmlns:a16="http://schemas.microsoft.com/office/drawing/2014/main" id="{BF77E5FC-C017-4D61-9425-DFA8C2E1006D}"/>
               </a:ext>
             </a:extLst>
           </p:cNvPr>
@@ -7752,7 +7752,7 @@
           <p:cNvPr id="15" name="">
             <a:extLst xmlns:a="http://schemas.openxmlformats.org/drawingml/2006/main">
               <a:ext uri="{FF2B5EF4-FFF2-40B4-BE49-F238E27FC236}">
-                <a16:creationId xmlns:a16="http://schemas.microsoft.com/office/drawing/2014/main" id="{37D33F6B-5819-4382-A063-0094B3A5FF94}"/>
+                <a16:creationId xmlns:a16="http://schemas.microsoft.com/office/drawing/2014/main" id="{BBF9AF73-C6BA-46FF-A6CB-FCF2ED7426DB}"/>
               </a:ext>
             </a:extLst>
           </p:cNvPr>
@@ -7816,7 +7816,7 @@
           <p:cNvPr id="16" name="">
             <a:extLst xmlns:a="http://schemas.openxmlformats.org/drawingml/2006/main">
               <a:ext uri="{FF2B5EF4-FFF2-40B4-BE49-F238E27FC236}">
-                <a16:creationId xmlns:a16="http://schemas.microsoft.com/office/drawing/2014/main" id="{8DA32741-F835-440C-AE8E-46D7E2B63E12}"/>
+                <a16:creationId xmlns:a16="http://schemas.microsoft.com/office/drawing/2014/main" id="{1D91A623-99FC-4744-82B5-8D0DB438081C}"/>
               </a:ext>
             </a:extLst>
           </p:cNvPr>
@@ -7851,7 +7851,7 @@
           <p:cNvPr id="17" name="">
             <a:extLst xmlns:a="http://schemas.openxmlformats.org/drawingml/2006/main">
               <a:ext uri="{FF2B5EF4-FFF2-40B4-BE49-F238E27FC236}">
-                <a16:creationId xmlns:a16="http://schemas.microsoft.com/office/drawing/2014/main" id="{668A7022-6065-4112-84BE-F1618FFD1A20}"/>
+                <a16:creationId xmlns:a16="http://schemas.microsoft.com/office/drawing/2014/main" id="{8F8FA8FE-5092-4E17-9ED0-C5EC0022C33F}"/>
               </a:ext>
             </a:extLst>
           </p:cNvPr>
@@ -7915,7 +7915,7 @@
           <p:cNvPr id="18" name="">
             <a:extLst xmlns:a="http://schemas.openxmlformats.org/drawingml/2006/main">
               <a:ext uri="{FF2B5EF4-FFF2-40B4-BE49-F238E27FC236}">
-                <a16:creationId xmlns:a16="http://schemas.microsoft.com/office/drawing/2014/main" id="{0963F35A-4B75-464D-A970-CDA995189A7C}"/>
+                <a16:creationId xmlns:a16="http://schemas.microsoft.com/office/drawing/2014/main" id="{4EB69EA6-B339-4616-8558-E870F1A86CB2}"/>
               </a:ext>
             </a:extLst>
           </p:cNvPr>
@@ -7950,7 +7950,7 @@
           <p:cNvPr id="19" name="">
             <a:extLst xmlns:a="http://schemas.openxmlformats.org/drawingml/2006/main">
               <a:ext uri="{FF2B5EF4-FFF2-40B4-BE49-F238E27FC236}">
-                <a16:creationId xmlns:a16="http://schemas.microsoft.com/office/drawing/2014/main" id="{3A63CFF2-2888-40CA-90F1-84AF883C8699}"/>
+                <a16:creationId xmlns:a16="http://schemas.microsoft.com/office/drawing/2014/main" id="{C7A3330A-6F71-4D5F-8EA0-64D56B53279A}"/>
               </a:ext>
             </a:extLst>
           </p:cNvPr>
@@ -8014,7 +8014,7 @@
           <p:cNvPr id="20" name="">
             <a:extLst xmlns:a="http://schemas.openxmlformats.org/drawingml/2006/main">
               <a:ext uri="{FF2B5EF4-FFF2-40B4-BE49-F238E27FC236}">
-                <a16:creationId xmlns:a16="http://schemas.microsoft.com/office/drawing/2014/main" id="{D38F9796-962C-44E2-9D4A-F1866E217372}"/>
+                <a16:creationId xmlns:a16="http://schemas.microsoft.com/office/drawing/2014/main" id="{ECF8B440-3B09-436B-8A31-A65F2AF8A2B6}"/>
               </a:ext>
             </a:extLst>
           </p:cNvPr>
@@ -8049,7 +8049,7 @@
           <p:cNvPr id="21" name="">
             <a:extLst xmlns:a="http://schemas.openxmlformats.org/drawingml/2006/main">
               <a:ext uri="{FF2B5EF4-FFF2-40B4-BE49-F238E27FC236}">
-                <a16:creationId xmlns:a16="http://schemas.microsoft.com/office/drawing/2014/main" id="{C2E7E4F1-F145-4542-9B05-E2AFD6E3A06E}"/>
+                <a16:creationId xmlns:a16="http://schemas.microsoft.com/office/drawing/2014/main" id="{362CF6EF-3372-4487-AC4B-19DDB6B5953E}"/>
               </a:ext>
             </a:extLst>
           </p:cNvPr>
@@ -8113,7 +8113,7 @@
           <p:cNvPr id="22" name="">
             <a:extLst xmlns:a="http://schemas.openxmlformats.org/drawingml/2006/main">
               <a:ext uri="{FF2B5EF4-FFF2-40B4-BE49-F238E27FC236}">
-                <a16:creationId xmlns:a16="http://schemas.microsoft.com/office/drawing/2014/main" id="{07DA1A42-8E2E-4D88-8C0E-1A95CA958194}"/>
+                <a16:creationId xmlns:a16="http://schemas.microsoft.com/office/drawing/2014/main" id="{47480F66-E25F-4B85-B6B0-DFBE151115CF}"/>
               </a:ext>
             </a:extLst>
           </p:cNvPr>
@@ -8177,7 +8177,7 @@
           <p:cNvPr id="23" name="">
             <a:extLst xmlns:a="http://schemas.openxmlformats.org/drawingml/2006/main">
               <a:ext uri="{FF2B5EF4-FFF2-40B4-BE49-F238E27FC236}">
-                <a16:creationId xmlns:a16="http://schemas.microsoft.com/office/drawing/2014/main" id="{742BA582-8575-416A-AF63-6B32E8898B44}"/>
+                <a16:creationId xmlns:a16="http://schemas.microsoft.com/office/drawing/2014/main" id="{AC74BC79-9EB2-4EB1-A75C-DEA592E6229D}"/>
               </a:ext>
             </a:extLst>
           </p:cNvPr>
@@ -8239,7 +8239,7 @@
     </p:spTree>
     <p:extLst>
       <p:ext uri="{BB962C8B-B14F-4D97-AF65-F5344CB8AC3E}">
-        <p14:creationId xmlns:p14="http://schemas.microsoft.com/office/powerpoint/2010/main" val="729896131"/>
+        <p14:creationId xmlns:p14="http://schemas.microsoft.com/office/powerpoint/2010/main" val="322950775"/>
       </p:ext>
     </p:extLst>
   </p:cSld>
@@ -8263,7 +8263,7 @@
           <p:cNvPr id="1" name="">
             <a:extLst xmlns:a="http://schemas.openxmlformats.org/drawingml/2006/main">
               <a:ext uri="{FF2B5EF4-FFF2-40B4-BE49-F238E27FC236}">
-                <a16:creationId xmlns:a16="http://schemas.microsoft.com/office/drawing/2014/main" id="{F045640B-4CA9-4BAA-9F26-176C0A9A7E53}"/>
+                <a16:creationId xmlns:a16="http://schemas.microsoft.com/office/drawing/2014/main" id="{E8BAFF8E-3BE3-4C0C-9CFF-4207746E1791}"/>
               </a:ext>
             </a:extLst>
           </p:cNvPr>
@@ -8298,7 +8298,7 @@
           <p:cNvPr id="2" name="">
             <a:extLst xmlns:a="http://schemas.openxmlformats.org/drawingml/2006/main">
               <a:ext uri="{FF2B5EF4-FFF2-40B4-BE49-F238E27FC236}">
-                <a16:creationId xmlns:a16="http://schemas.microsoft.com/office/drawing/2014/main" id="{93B05243-F854-4AFB-B1F4-416155CAE96B}"/>
+                <a16:creationId xmlns:a16="http://schemas.microsoft.com/office/drawing/2014/main" id="{C6A465DA-A521-463A-8E0C-592E3A860287}"/>
               </a:ext>
             </a:extLst>
           </p:cNvPr>
@@ -8362,7 +8362,7 @@
           <p:cNvPr id="3" name="">
             <a:extLst xmlns:a="http://schemas.openxmlformats.org/drawingml/2006/main">
               <a:ext uri="{FF2B5EF4-FFF2-40B4-BE49-F238E27FC236}">
-                <a16:creationId xmlns:a16="http://schemas.microsoft.com/office/drawing/2014/main" id="{CC7D2A19-0450-4C80-ABEA-893D6C723A70}"/>
+                <a16:creationId xmlns:a16="http://schemas.microsoft.com/office/drawing/2014/main" id="{0F2341A8-EE8F-49B9-97BF-7678A1A673AF}"/>
               </a:ext>
             </a:extLst>
           </p:cNvPr>
@@ -8426,7 +8426,7 @@
           <p:cNvPr id="4" name="">
             <a:extLst xmlns:a="http://schemas.openxmlformats.org/drawingml/2006/main">
               <a:ext uri="{FF2B5EF4-FFF2-40B4-BE49-F238E27FC236}">
-                <a16:creationId xmlns:a16="http://schemas.microsoft.com/office/drawing/2014/main" id="{27467FC0-FE46-4745-8212-C9AD920C683C}"/>
+                <a16:creationId xmlns:a16="http://schemas.microsoft.com/office/drawing/2014/main" id="{C8159C9D-01BF-41C9-A6D4-3FD6C78E7EAD}"/>
               </a:ext>
             </a:extLst>
           </p:cNvPr>
@@ -8490,7 +8490,7 @@
           <p:cNvPr id="5" name="">
             <a:extLst xmlns:a="http://schemas.openxmlformats.org/drawingml/2006/main">
               <a:ext uri="{FF2B5EF4-FFF2-40B4-BE49-F238E27FC236}">
-                <a16:creationId xmlns:a16="http://schemas.microsoft.com/office/drawing/2014/main" id="{84C1024B-2AED-4416-8E28-0F0A6392B2D7}"/>
+                <a16:creationId xmlns:a16="http://schemas.microsoft.com/office/drawing/2014/main" id="{18F1DB73-921A-4AC8-8224-E830AD2F49E0}"/>
               </a:ext>
             </a:extLst>
           </p:cNvPr>
@@ -8525,7 +8525,7 @@
           <p:cNvPr id="6" name="">
             <a:extLst xmlns:a="http://schemas.openxmlformats.org/drawingml/2006/main">
               <a:ext uri="{FF2B5EF4-FFF2-40B4-BE49-F238E27FC236}">
-                <a16:creationId xmlns:a16="http://schemas.microsoft.com/office/drawing/2014/main" id="{04361713-77C0-4A0A-A462-B570709FADFC}"/>
+                <a16:creationId xmlns:a16="http://schemas.microsoft.com/office/drawing/2014/main" id="{D606767C-F73E-4A60-89CE-164A820DD1EE}"/>
               </a:ext>
             </a:extLst>
           </p:cNvPr>
@@ -8560,7 +8560,7 @@
           <p:cNvPr id="7" name="">
             <a:extLst xmlns:a="http://schemas.openxmlformats.org/drawingml/2006/main">
               <a:ext uri="{FF2B5EF4-FFF2-40B4-BE49-F238E27FC236}">
-                <a16:creationId xmlns:a16="http://schemas.microsoft.com/office/drawing/2014/main" id="{BC2466B3-F87B-42FE-9030-9887F811A259}"/>
+                <a16:creationId xmlns:a16="http://schemas.microsoft.com/office/drawing/2014/main" id="{DFC0FC45-F0EE-4872-85C3-E51D9FE4AA57}"/>
               </a:ext>
             </a:extLst>
           </p:cNvPr>
@@ -8624,7 +8624,7 @@
           <p:cNvPr id="8" name="">
             <a:extLst xmlns:a="http://schemas.openxmlformats.org/drawingml/2006/main">
               <a:ext uri="{FF2B5EF4-FFF2-40B4-BE49-F238E27FC236}">
-                <a16:creationId xmlns:a16="http://schemas.microsoft.com/office/drawing/2014/main" id="{FD168DCA-1BFD-4121-96DA-8503F9BBA666}"/>
+                <a16:creationId xmlns:a16="http://schemas.microsoft.com/office/drawing/2014/main" id="{EA547801-EFA1-4F95-91D4-E375AFD5C66C}"/>
               </a:ext>
             </a:extLst>
           </p:cNvPr>
@@ -8659,7 +8659,7 @@
           <p:cNvPr id="9" name="">
             <a:extLst xmlns:a="http://schemas.openxmlformats.org/drawingml/2006/main">
               <a:ext uri="{FF2B5EF4-FFF2-40B4-BE49-F238E27FC236}">
-                <a16:creationId xmlns:a16="http://schemas.microsoft.com/office/drawing/2014/main" id="{D008E8CF-ED69-40DC-900C-10901082D862}"/>
+                <a16:creationId xmlns:a16="http://schemas.microsoft.com/office/drawing/2014/main" id="{893BCCE5-2316-4D2A-AD66-FF641B09C7B6}"/>
               </a:ext>
             </a:extLst>
           </p:cNvPr>
@@ -8723,7 +8723,7 @@
           <p:cNvPr id="10" name="">
             <a:extLst xmlns:a="http://schemas.openxmlformats.org/drawingml/2006/main">
               <a:ext uri="{FF2B5EF4-FFF2-40B4-BE49-F238E27FC236}">
-                <a16:creationId xmlns:a16="http://schemas.microsoft.com/office/drawing/2014/main" id="{59EADC86-6CC0-434E-8010-8A91EA497FC3}"/>
+                <a16:creationId xmlns:a16="http://schemas.microsoft.com/office/drawing/2014/main" id="{38BA2398-3C26-4138-9B91-AFBE913A91AB}"/>
               </a:ext>
             </a:extLst>
           </p:cNvPr>
@@ -8758,7 +8758,7 @@
           <p:cNvPr id="11" name="">
             <a:extLst xmlns:a="http://schemas.openxmlformats.org/drawingml/2006/main">
               <a:ext uri="{FF2B5EF4-FFF2-40B4-BE49-F238E27FC236}">
-                <a16:creationId xmlns:a16="http://schemas.microsoft.com/office/drawing/2014/main" id="{57A44E33-3BBC-42B6-8FF7-54879E5910CD}"/>
+                <a16:creationId xmlns:a16="http://schemas.microsoft.com/office/drawing/2014/main" id="{86A022BC-0384-4349-B42B-F3A13B0143A9}"/>
               </a:ext>
             </a:extLst>
           </p:cNvPr>
@@ -8822,7 +8822,7 @@
           <p:cNvPr id="12" name="">
             <a:extLst xmlns:a="http://schemas.openxmlformats.org/drawingml/2006/main">
               <a:ext uri="{FF2B5EF4-FFF2-40B4-BE49-F238E27FC236}">
-                <a16:creationId xmlns:a16="http://schemas.microsoft.com/office/drawing/2014/main" id="{47C7F45A-1D98-4CBE-8F24-AC2D83719190}"/>
+                <a16:creationId xmlns:a16="http://schemas.microsoft.com/office/drawing/2014/main" id="{931FE21D-56B9-4958-ACE4-317D47396711}"/>
               </a:ext>
             </a:extLst>
           </p:cNvPr>
@@ -8857,7 +8857,7 @@
           <p:cNvPr id="13" name="">
             <a:extLst xmlns:a="http://schemas.openxmlformats.org/drawingml/2006/main">
               <a:ext uri="{FF2B5EF4-FFF2-40B4-BE49-F238E27FC236}">
-                <a16:creationId xmlns:a16="http://schemas.microsoft.com/office/drawing/2014/main" id="{5562C0A5-795C-4252-A7EA-7F5D1D6F698D}"/>
+                <a16:creationId xmlns:a16="http://schemas.microsoft.com/office/drawing/2014/main" id="{F9BCDD94-4795-4A6D-BF3B-47160D76D5F4}"/>
               </a:ext>
             </a:extLst>
           </p:cNvPr>
@@ -8921,7 +8921,7 @@
           <p:cNvPr id="14" name="">
             <a:extLst xmlns:a="http://schemas.openxmlformats.org/drawingml/2006/main">
               <a:ext uri="{FF2B5EF4-FFF2-40B4-BE49-F238E27FC236}">
-                <a16:creationId xmlns:a16="http://schemas.microsoft.com/office/drawing/2014/main" id="{71528D02-1FBF-4216-9213-90EECF61CAF5}"/>
+                <a16:creationId xmlns:a16="http://schemas.microsoft.com/office/drawing/2014/main" id="{C536BC7A-0C13-415C-9196-B20CE76B52B5}"/>
               </a:ext>
             </a:extLst>
           </p:cNvPr>
@@ -8958,7 +8958,7 @@
           <p:nvPr/>
         </p:nvPicPr>
         <p:blipFill>
-          <a:blip xmlns:r="http://schemas.openxmlformats.org/officeDocument/2006/relationships" xmlns:a="http://schemas.openxmlformats.org/drawingml/2006/main" r:embed="R1c72521819c642fa"/>
+          <a:blip xmlns:r="http://schemas.openxmlformats.org/officeDocument/2006/relationships" xmlns:a="http://schemas.openxmlformats.org/drawingml/2006/main" r:embed="Rcd46ef43d1a84a64"/>
           <a:stretch xmlns:a="http://schemas.openxmlformats.org/drawingml/2006/main"/>
         </p:blipFill>
         <p:spPr>
@@ -8976,7 +8976,7 @@
           <p:cNvPr id="16" name="">
             <a:extLst xmlns:a="http://schemas.openxmlformats.org/drawingml/2006/main">
               <a:ext uri="{FF2B5EF4-FFF2-40B4-BE49-F238E27FC236}">
-                <a16:creationId xmlns:a16="http://schemas.microsoft.com/office/drawing/2014/main" id="{0E219F2A-D07F-4F0B-96F0-6A8D2ADDF4D9}"/>
+                <a16:creationId xmlns:a16="http://schemas.microsoft.com/office/drawing/2014/main" id="{57F9AD5B-2BB9-4528-BF76-38D459F75055}"/>
               </a:ext>
             </a:extLst>
           </p:cNvPr>
@@ -9040,7 +9040,7 @@
           <p:cNvPr id="17" name="">
             <a:extLst xmlns:a="http://schemas.openxmlformats.org/drawingml/2006/main">
               <a:ext uri="{FF2B5EF4-FFF2-40B4-BE49-F238E27FC236}">
-                <a16:creationId xmlns:a16="http://schemas.microsoft.com/office/drawing/2014/main" id="{3A3958B2-3FD2-4007-B81D-05CBDFCB9C9F}"/>
+                <a16:creationId xmlns:a16="http://schemas.microsoft.com/office/drawing/2014/main" id="{D1C1F445-3F12-45B3-A330-487C85E6A55D}"/>
               </a:ext>
             </a:extLst>
           </p:cNvPr>
@@ -9102,7 +9102,7 @@
     </p:spTree>
     <p:extLst>
       <p:ext uri="{BB962C8B-B14F-4D97-AF65-F5344CB8AC3E}">
-        <p14:creationId xmlns:p14="http://schemas.microsoft.com/office/powerpoint/2010/main" val="1441089267"/>
+        <p14:creationId xmlns:p14="http://schemas.microsoft.com/office/powerpoint/2010/main" val="1756282680"/>
       </p:ext>
     </p:extLst>
   </p:cSld>
@@ -9126,7 +9126,7 @@
           <p:cNvPr id="1" name="">
             <a:extLst xmlns:a="http://schemas.openxmlformats.org/drawingml/2006/main">
               <a:ext uri="{FF2B5EF4-FFF2-40B4-BE49-F238E27FC236}">
-                <a16:creationId xmlns:a16="http://schemas.microsoft.com/office/drawing/2014/main" id="{B3A9CD2A-1810-437A-92BC-E3D309381F45}"/>
+                <a16:creationId xmlns:a16="http://schemas.microsoft.com/office/drawing/2014/main" id="{E4E7D9BF-25D9-4B18-ADC4-85634C891DEC}"/>
               </a:ext>
             </a:extLst>
           </p:cNvPr>
@@ -9161,7 +9161,7 @@
           <p:cNvPr id="2" name="">
             <a:extLst xmlns:a="http://schemas.openxmlformats.org/drawingml/2006/main">
               <a:ext uri="{FF2B5EF4-FFF2-40B4-BE49-F238E27FC236}">
-                <a16:creationId xmlns:a16="http://schemas.microsoft.com/office/drawing/2014/main" id="{FAE21489-26C6-48E5-BE55-1588E8F9402F}"/>
+                <a16:creationId xmlns:a16="http://schemas.microsoft.com/office/drawing/2014/main" id="{D9946A93-A335-4546-970D-DABDBF6CCB94}"/>
               </a:ext>
             </a:extLst>
           </p:cNvPr>
@@ -9225,7 +9225,7 @@
           <p:cNvPr id="3" name="">
             <a:extLst xmlns:a="http://schemas.openxmlformats.org/drawingml/2006/main">
               <a:ext uri="{FF2B5EF4-FFF2-40B4-BE49-F238E27FC236}">
-                <a16:creationId xmlns:a16="http://schemas.microsoft.com/office/drawing/2014/main" id="{91FE5285-9AD5-4EF4-A329-B3BC01CB3CE5}"/>
+                <a16:creationId xmlns:a16="http://schemas.microsoft.com/office/drawing/2014/main" id="{C182C51D-2EFA-416A-BA8E-95D70A68CDE6}"/>
               </a:ext>
             </a:extLst>
           </p:cNvPr>
@@ -9289,7 +9289,7 @@
           <p:cNvPr id="4" name="">
             <a:extLst xmlns:a="http://schemas.openxmlformats.org/drawingml/2006/main">
               <a:ext uri="{FF2B5EF4-FFF2-40B4-BE49-F238E27FC236}">
-                <a16:creationId xmlns:a16="http://schemas.microsoft.com/office/drawing/2014/main" id="{6F40C4F7-3483-48AF-8A01-1403F73559F9}"/>
+                <a16:creationId xmlns:a16="http://schemas.microsoft.com/office/drawing/2014/main" id="{899225C9-C7A3-4CA4-B92D-EF6CD9BCE1E6}"/>
               </a:ext>
             </a:extLst>
           </p:cNvPr>
@@ -9353,7 +9353,7 @@
           <p:cNvPr id="5" name="">
             <a:extLst xmlns:a="http://schemas.openxmlformats.org/drawingml/2006/main">
               <a:ext uri="{FF2B5EF4-FFF2-40B4-BE49-F238E27FC236}">
-                <a16:creationId xmlns:a16="http://schemas.microsoft.com/office/drawing/2014/main" id="{FABC747E-425A-4839-AF79-0C1D333AD50B}"/>
+                <a16:creationId xmlns:a16="http://schemas.microsoft.com/office/drawing/2014/main" id="{2943FCA7-A736-43E5-B482-F853AE8192CF}"/>
               </a:ext>
             </a:extLst>
           </p:cNvPr>
@@ -9388,7 +9388,7 @@
           <p:cNvPr id="6" name="">
             <a:extLst xmlns:a="http://schemas.openxmlformats.org/drawingml/2006/main">
               <a:ext uri="{FF2B5EF4-FFF2-40B4-BE49-F238E27FC236}">
-                <a16:creationId xmlns:a16="http://schemas.microsoft.com/office/drawing/2014/main" id="{C98A335D-09B9-457B-8549-5D7528AF37F0}"/>
+                <a16:creationId xmlns:a16="http://schemas.microsoft.com/office/drawing/2014/main" id="{1B7FF29C-3943-48B0-9833-2D12B3957547}"/>
               </a:ext>
             </a:extLst>
           </p:cNvPr>
@@ -9423,7 +9423,7 @@
           <p:cNvPr id="7" name="">
             <a:extLst xmlns:a="http://schemas.openxmlformats.org/drawingml/2006/main">
               <a:ext uri="{FF2B5EF4-FFF2-40B4-BE49-F238E27FC236}">
-                <a16:creationId xmlns:a16="http://schemas.microsoft.com/office/drawing/2014/main" id="{759E7C35-B07D-459C-BF72-E15B56FE5C38}"/>
+                <a16:creationId xmlns:a16="http://schemas.microsoft.com/office/drawing/2014/main" id="{EA2BBD47-1576-4B65-9A6D-1D47CFFFA751}"/>
               </a:ext>
             </a:extLst>
           </p:cNvPr>
@@ -9487,7 +9487,7 @@
           <p:cNvPr id="8" name="">
             <a:extLst xmlns:a="http://schemas.openxmlformats.org/drawingml/2006/main">
               <a:ext uri="{FF2B5EF4-FFF2-40B4-BE49-F238E27FC236}">
-                <a16:creationId xmlns:a16="http://schemas.microsoft.com/office/drawing/2014/main" id="{62C042DD-C6F5-4C13-A5CB-E2BE4952673F}"/>
+                <a16:creationId xmlns:a16="http://schemas.microsoft.com/office/drawing/2014/main" id="{3416A404-DFED-458B-A9A6-4F6EC2EDF89E}"/>
               </a:ext>
             </a:extLst>
           </p:cNvPr>
@@ -9522,7 +9522,7 @@
           <p:cNvPr id="9" name="">
             <a:extLst xmlns:a="http://schemas.openxmlformats.org/drawingml/2006/main">
               <a:ext uri="{FF2B5EF4-FFF2-40B4-BE49-F238E27FC236}">
-                <a16:creationId xmlns:a16="http://schemas.microsoft.com/office/drawing/2014/main" id="{10EEBB63-1E8B-4C2E-8605-3DCBEFC205B6}"/>
+                <a16:creationId xmlns:a16="http://schemas.microsoft.com/office/drawing/2014/main" id="{B19C8283-F992-4FEC-9FAD-3F6FCF1940E2}"/>
               </a:ext>
             </a:extLst>
           </p:cNvPr>
@@ -9586,7 +9586,7 @@
           <p:cNvPr id="10" name="">
             <a:extLst xmlns:a="http://schemas.openxmlformats.org/drawingml/2006/main">
               <a:ext uri="{FF2B5EF4-FFF2-40B4-BE49-F238E27FC236}">
-                <a16:creationId xmlns:a16="http://schemas.microsoft.com/office/drawing/2014/main" id="{40980E12-8E56-4B53-9B90-0664CEDDF6A8}"/>
+                <a16:creationId xmlns:a16="http://schemas.microsoft.com/office/drawing/2014/main" id="{2A684DF0-50C3-4188-A7A2-F73916C23B58}"/>
               </a:ext>
             </a:extLst>
           </p:cNvPr>
@@ -9621,7 +9621,7 @@
           <p:cNvPr id="11" name="">
             <a:extLst xmlns:a="http://schemas.openxmlformats.org/drawingml/2006/main">
               <a:ext uri="{FF2B5EF4-FFF2-40B4-BE49-F238E27FC236}">
-                <a16:creationId xmlns:a16="http://schemas.microsoft.com/office/drawing/2014/main" id="{3B055047-EA1E-4975-A907-2BD9004A8D07}"/>
+                <a16:creationId xmlns:a16="http://schemas.microsoft.com/office/drawing/2014/main" id="{FF10D8BA-2BF0-4123-BEAD-99C4814D33D8}"/>
               </a:ext>
             </a:extLst>
           </p:cNvPr>
@@ -9685,7 +9685,7 @@
           <p:cNvPr id="12" name="">
             <a:extLst xmlns:a="http://schemas.openxmlformats.org/drawingml/2006/main">
               <a:ext uri="{FF2B5EF4-FFF2-40B4-BE49-F238E27FC236}">
-                <a16:creationId xmlns:a16="http://schemas.microsoft.com/office/drawing/2014/main" id="{8F223DEE-25DA-4BB7-A03F-62E72DC86754}"/>
+                <a16:creationId xmlns:a16="http://schemas.microsoft.com/office/drawing/2014/main" id="{68285AD2-14BB-4EBC-8034-A6CD805026BF}"/>
               </a:ext>
             </a:extLst>
           </p:cNvPr>
@@ -9722,7 +9722,7 @@
           <p:nvPr/>
         </p:nvPicPr>
         <p:blipFill>
-          <a:blip xmlns:r="http://schemas.openxmlformats.org/officeDocument/2006/relationships" xmlns:a="http://schemas.openxmlformats.org/drawingml/2006/main" r:embed="R71961783c8fe467a"/>
+          <a:blip xmlns:r="http://schemas.openxmlformats.org/officeDocument/2006/relationships" xmlns:a="http://schemas.openxmlformats.org/drawingml/2006/main" r:embed="R4db463276cff4a00"/>
           <a:stretch xmlns:a="http://schemas.openxmlformats.org/drawingml/2006/main"/>
         </p:blipFill>
         <p:spPr>
@@ -9740,7 +9740,7 @@
           <p:cNvPr id="14" name="">
             <a:extLst xmlns:a="http://schemas.openxmlformats.org/drawingml/2006/main">
               <a:ext uri="{FF2B5EF4-FFF2-40B4-BE49-F238E27FC236}">
-                <a16:creationId xmlns:a16="http://schemas.microsoft.com/office/drawing/2014/main" id="{4809E3F7-525C-4D20-9D9E-F7C78BE335F0}"/>
+                <a16:creationId xmlns:a16="http://schemas.microsoft.com/office/drawing/2014/main" id="{62C754F6-D03B-4D11-8ADE-682EC0CB6A01}"/>
               </a:ext>
             </a:extLst>
           </p:cNvPr>
@@ -9773,7 +9773,7 @@
           <p:cNvPr id="15" name="">
             <a:extLst xmlns:a="http://schemas.openxmlformats.org/drawingml/2006/main">
               <a:ext uri="{FF2B5EF4-FFF2-40B4-BE49-F238E27FC236}">
-                <a16:creationId xmlns:a16="http://schemas.microsoft.com/office/drawing/2014/main" id="{4B4CAA79-D383-414C-A6FC-053292B4FE6D}"/>
+                <a16:creationId xmlns:a16="http://schemas.microsoft.com/office/drawing/2014/main" id="{990B2A2B-4DF7-44BB-A9BC-37FF0534E1C7}"/>
               </a:ext>
             </a:extLst>
           </p:cNvPr>
@@ -9837,7 +9837,7 @@
           <p:cNvPr id="16" name="">
             <a:extLst xmlns:a="http://schemas.openxmlformats.org/drawingml/2006/main">
               <a:ext uri="{FF2B5EF4-FFF2-40B4-BE49-F238E27FC236}">
-                <a16:creationId xmlns:a16="http://schemas.microsoft.com/office/drawing/2014/main" id="{34B5DD69-E8EC-43E4-BB2C-2D2A0CBB467C}"/>
+                <a16:creationId xmlns:a16="http://schemas.microsoft.com/office/drawing/2014/main" id="{74463179-C033-41AE-9BEE-D654AEBD864E}"/>
               </a:ext>
             </a:extLst>
           </p:cNvPr>
@@ -9901,7 +9901,7 @@
           <p:cNvPr id="17" name="">
             <a:extLst xmlns:a="http://schemas.openxmlformats.org/drawingml/2006/main">
               <a:ext uri="{FF2B5EF4-FFF2-40B4-BE49-F238E27FC236}">
-                <a16:creationId xmlns:a16="http://schemas.microsoft.com/office/drawing/2014/main" id="{F4E1D969-D148-4E6C-8C31-4E908EA3BA8D}"/>
+                <a16:creationId xmlns:a16="http://schemas.microsoft.com/office/drawing/2014/main" id="{83A798AD-9177-4582-ABA8-5DBFC7AF8E07}"/>
               </a:ext>
             </a:extLst>
           </p:cNvPr>
@@ -9963,7 +9963,7 @@
     </p:spTree>
     <p:extLst>
       <p:ext uri="{BB962C8B-B14F-4D97-AF65-F5344CB8AC3E}">
-        <p14:creationId xmlns:p14="http://schemas.microsoft.com/office/powerpoint/2010/main" val="930184337"/>
+        <p14:creationId xmlns:p14="http://schemas.microsoft.com/office/powerpoint/2010/main" val="297669076"/>
       </p:ext>
     </p:extLst>
   </p:cSld>
@@ -9987,7 +9987,7 @@
           <p:cNvPr id="1" name="">
             <a:extLst xmlns:a="http://schemas.openxmlformats.org/drawingml/2006/main">
               <a:ext uri="{FF2B5EF4-FFF2-40B4-BE49-F238E27FC236}">
-                <a16:creationId xmlns:a16="http://schemas.microsoft.com/office/drawing/2014/main" id="{78F902A0-93EE-4DE3-9632-0088FAFFF1E5}"/>
+                <a16:creationId xmlns:a16="http://schemas.microsoft.com/office/drawing/2014/main" id="{D48D313B-5FE4-4673-8B93-C63456E220C8}"/>
               </a:ext>
             </a:extLst>
           </p:cNvPr>
@@ -10022,7 +10022,7 @@
           <p:cNvPr id="2" name="">
             <a:extLst xmlns:a="http://schemas.openxmlformats.org/drawingml/2006/main">
               <a:ext uri="{FF2B5EF4-FFF2-40B4-BE49-F238E27FC236}">
-                <a16:creationId xmlns:a16="http://schemas.microsoft.com/office/drawing/2014/main" id="{EF0AB2AC-4462-4AA1-A323-90D9F967E0DA}"/>
+                <a16:creationId xmlns:a16="http://schemas.microsoft.com/office/drawing/2014/main" id="{959305C4-3A4F-46BE-9F3B-E889285F311B}"/>
               </a:ext>
             </a:extLst>
           </p:cNvPr>
@@ -10086,7 +10086,7 @@
           <p:cNvPr id="3" name="">
             <a:extLst xmlns:a="http://schemas.openxmlformats.org/drawingml/2006/main">
               <a:ext uri="{FF2B5EF4-FFF2-40B4-BE49-F238E27FC236}">
-                <a16:creationId xmlns:a16="http://schemas.microsoft.com/office/drawing/2014/main" id="{556DD3F9-AB12-4D89-BB20-670AF8FE9811}"/>
+                <a16:creationId xmlns:a16="http://schemas.microsoft.com/office/drawing/2014/main" id="{01316F6F-02CE-4ABE-A962-EAEB1E9148AB}"/>
               </a:ext>
             </a:extLst>
           </p:cNvPr>
@@ -10150,7 +10150,7 @@
           <p:cNvPr id="4" name="">
             <a:extLst xmlns:a="http://schemas.openxmlformats.org/drawingml/2006/main">
               <a:ext uri="{FF2B5EF4-FFF2-40B4-BE49-F238E27FC236}">
-                <a16:creationId xmlns:a16="http://schemas.microsoft.com/office/drawing/2014/main" id="{7A68367E-F2D9-4871-A311-989E72945D1B}"/>
+                <a16:creationId xmlns:a16="http://schemas.microsoft.com/office/drawing/2014/main" id="{11971BB6-FDB3-4BF7-BEF3-BC5E42E1FF11}"/>
               </a:ext>
             </a:extLst>
           </p:cNvPr>
@@ -10214,7 +10214,7 @@
           <p:cNvPr id="5" name="">
             <a:extLst xmlns:a="http://schemas.openxmlformats.org/drawingml/2006/main">
               <a:ext uri="{FF2B5EF4-FFF2-40B4-BE49-F238E27FC236}">
-                <a16:creationId xmlns:a16="http://schemas.microsoft.com/office/drawing/2014/main" id="{4E5E7D02-CFB8-4827-9FBB-1420677EA7C6}"/>
+                <a16:creationId xmlns:a16="http://schemas.microsoft.com/office/drawing/2014/main" id="{B9938585-6CBB-4DE1-9949-34794B9A55F5}"/>
               </a:ext>
             </a:extLst>
           </p:cNvPr>
@@ -10249,7 +10249,7 @@
           <p:cNvPr id="6" name="">
             <a:extLst xmlns:a="http://schemas.openxmlformats.org/drawingml/2006/main">
               <a:ext uri="{FF2B5EF4-FFF2-40B4-BE49-F238E27FC236}">
-                <a16:creationId xmlns:a16="http://schemas.microsoft.com/office/drawing/2014/main" id="{9CD445C8-4A08-46AD-A3DD-95D7DB04F5C8}"/>
+                <a16:creationId xmlns:a16="http://schemas.microsoft.com/office/drawing/2014/main" id="{9217D7FF-7EFC-4813-B847-B06AC398693F}"/>
               </a:ext>
             </a:extLst>
           </p:cNvPr>
@@ -10303,7 +10303,7 @@
                 <a:ea typeface="Aptos Display"/>
                 <a:cs typeface="Aptos Display"/>
               </a:rPr>
-              <a:t>48</a:t>
+              <a:t>56</a:t>
             </a:r>
           </a:p>
         </p:txBody>
@@ -10313,7 +10313,7 @@
           <p:cNvPr id="7" name="">
             <a:extLst xmlns:a="http://schemas.openxmlformats.org/drawingml/2006/main">
               <a:ext uri="{FF2B5EF4-FFF2-40B4-BE49-F238E27FC236}">
-                <a16:creationId xmlns:a16="http://schemas.microsoft.com/office/drawing/2014/main" id="{8068620D-CCA2-4EA8-8933-274CCAE22A2E}"/>
+                <a16:creationId xmlns:a16="http://schemas.microsoft.com/office/drawing/2014/main" id="{0DBAD7CA-6469-4670-82CF-4B84333073A1}"/>
               </a:ext>
             </a:extLst>
           </p:cNvPr>
@@ -10377,7 +10377,7 @@
           <p:cNvPr id="8" name="">
             <a:extLst xmlns:a="http://schemas.openxmlformats.org/drawingml/2006/main">
               <a:ext uri="{FF2B5EF4-FFF2-40B4-BE49-F238E27FC236}">
-                <a16:creationId xmlns:a16="http://schemas.microsoft.com/office/drawing/2014/main" id="{19CD4FF8-FD82-4A8C-ABBB-F65861B9EB8A}"/>
+                <a16:creationId xmlns:a16="http://schemas.microsoft.com/office/drawing/2014/main" id="{23E61E32-0D00-4A39-9A50-542EE290F16F}"/>
               </a:ext>
             </a:extLst>
           </p:cNvPr>
@@ -10431,7 +10431,7 @@
                 <a:ea typeface="Aptos Display"/>
                 <a:cs typeface="Aptos Display"/>
               </a:rPr>
-              <a:t>1405KB</a:t>
+              <a:t>2355KB</a:t>
             </a:r>
           </a:p>
         </p:txBody>
@@ -10441,7 +10441,7 @@
           <p:cNvPr id="9" name="">
             <a:extLst xmlns:a="http://schemas.openxmlformats.org/drawingml/2006/main">
               <a:ext uri="{FF2B5EF4-FFF2-40B4-BE49-F238E27FC236}">
-                <a16:creationId xmlns:a16="http://schemas.microsoft.com/office/drawing/2014/main" id="{ACA339A0-19EC-4461-A78D-1F2B71997519}"/>
+                <a16:creationId xmlns:a16="http://schemas.microsoft.com/office/drawing/2014/main" id="{608303B9-BD16-4881-8008-D7B8A82A2235}"/>
               </a:ext>
             </a:extLst>
           </p:cNvPr>
@@ -10505,7 +10505,7 @@
           <p:cNvPr id="10" name="">
             <a:extLst xmlns:a="http://schemas.openxmlformats.org/drawingml/2006/main">
               <a:ext uri="{FF2B5EF4-FFF2-40B4-BE49-F238E27FC236}">
-                <a16:creationId xmlns:a16="http://schemas.microsoft.com/office/drawing/2014/main" id="{42F08B8A-5478-43BD-B6E7-FF5D3EC0EF6B}"/>
+                <a16:creationId xmlns:a16="http://schemas.microsoft.com/office/drawing/2014/main" id="{0A31A83D-FC10-4A36-9136-83F86ED49CEC}"/>
               </a:ext>
             </a:extLst>
           </p:cNvPr>
@@ -10569,7 +10569,7 @@
           <p:cNvPr id="11" name="">
             <a:extLst xmlns:a="http://schemas.openxmlformats.org/drawingml/2006/main">
               <a:ext uri="{FF2B5EF4-FFF2-40B4-BE49-F238E27FC236}">
-                <a16:creationId xmlns:a16="http://schemas.microsoft.com/office/drawing/2014/main" id="{BB77082C-82F1-4284-AC0A-3849591D00F9}"/>
+                <a16:creationId xmlns:a16="http://schemas.microsoft.com/office/drawing/2014/main" id="{CA047BD4-3C9A-4A3F-BD14-3EF5830B39AD}"/>
               </a:ext>
             </a:extLst>
           </p:cNvPr>
@@ -10633,7 +10633,7 @@
           <p:cNvPr id="12" name="">
             <a:extLst xmlns:a="http://schemas.openxmlformats.org/drawingml/2006/main">
               <a:ext uri="{FF2B5EF4-FFF2-40B4-BE49-F238E27FC236}">
-                <a16:creationId xmlns:a16="http://schemas.microsoft.com/office/drawing/2014/main" id="{425AB26E-DEB5-49F5-93AA-CAEBE30E1E0A}"/>
+                <a16:creationId xmlns:a16="http://schemas.microsoft.com/office/drawing/2014/main" id="{0B01EA63-74D2-47CB-ACA7-C9843C20B9DB}"/>
               </a:ext>
             </a:extLst>
           </p:cNvPr>
@@ -10697,7 +10697,7 @@
           <p:cNvPr id="13" name="">
             <a:extLst xmlns:a="http://schemas.openxmlformats.org/drawingml/2006/main">
               <a:ext uri="{FF2B5EF4-FFF2-40B4-BE49-F238E27FC236}">
-                <a16:creationId xmlns:a16="http://schemas.microsoft.com/office/drawing/2014/main" id="{1C7630B5-6880-4BC8-8B4B-8D1B21692451}"/>
+                <a16:creationId xmlns:a16="http://schemas.microsoft.com/office/drawing/2014/main" id="{BE109FAC-90B5-4CA9-B477-EC5FB5113A9D}"/>
               </a:ext>
             </a:extLst>
           </p:cNvPr>
@@ -10761,7 +10761,7 @@
           <p:cNvPr id="14" name="">
             <a:extLst xmlns:a="http://schemas.openxmlformats.org/drawingml/2006/main">
               <a:ext uri="{FF2B5EF4-FFF2-40B4-BE49-F238E27FC236}">
-                <a16:creationId xmlns:a16="http://schemas.microsoft.com/office/drawing/2014/main" id="{02739DB8-5999-4EF3-A406-135D95E04A2D}"/>
+                <a16:creationId xmlns:a16="http://schemas.microsoft.com/office/drawing/2014/main" id="{006F75C2-89FD-4B81-9547-02A969508091}"/>
               </a:ext>
             </a:extLst>
           </p:cNvPr>
@@ -10796,7 +10796,7 @@
           <p:cNvPr id="15" name="">
             <a:extLst xmlns:a="http://schemas.openxmlformats.org/drawingml/2006/main">
               <a:ext uri="{FF2B5EF4-FFF2-40B4-BE49-F238E27FC236}">
-                <a16:creationId xmlns:a16="http://schemas.microsoft.com/office/drawing/2014/main" id="{2AD02A8C-3547-4F17-908D-DB5C96F93553}"/>
+                <a16:creationId xmlns:a16="http://schemas.microsoft.com/office/drawing/2014/main" id="{CC4B2022-0957-46A7-9B98-E20AA5C31D90}"/>
               </a:ext>
             </a:extLst>
           </p:cNvPr>
@@ -10860,7 +10860,7 @@
           <p:cNvPr id="16" name="">
             <a:extLst xmlns:a="http://schemas.openxmlformats.org/drawingml/2006/main">
               <a:ext uri="{FF2B5EF4-FFF2-40B4-BE49-F238E27FC236}">
-                <a16:creationId xmlns:a16="http://schemas.microsoft.com/office/drawing/2014/main" id="{734AFC50-63B5-4DC0-8DF4-5DB05C127648}"/>
+                <a16:creationId xmlns:a16="http://schemas.microsoft.com/office/drawing/2014/main" id="{8E2B10D1-23CF-481D-9ED3-FD9796614EC9}"/>
               </a:ext>
             </a:extLst>
           </p:cNvPr>
@@ -10895,7 +10895,7 @@
           <p:cNvPr id="17" name="">
             <a:extLst xmlns:a="http://schemas.openxmlformats.org/drawingml/2006/main">
               <a:ext uri="{FF2B5EF4-FFF2-40B4-BE49-F238E27FC236}">
-                <a16:creationId xmlns:a16="http://schemas.microsoft.com/office/drawing/2014/main" id="{5FE71BEB-E6B6-4DA4-A10F-B795AE2ED49A}"/>
+                <a16:creationId xmlns:a16="http://schemas.microsoft.com/office/drawing/2014/main" id="{AB6A282A-597F-4876-BADB-6FC10762029A}"/>
               </a:ext>
             </a:extLst>
           </p:cNvPr>
@@ -10959,7 +10959,7 @@
           <p:cNvPr id="18" name="">
             <a:extLst xmlns:a="http://schemas.openxmlformats.org/drawingml/2006/main">
               <a:ext uri="{FF2B5EF4-FFF2-40B4-BE49-F238E27FC236}">
-                <a16:creationId xmlns:a16="http://schemas.microsoft.com/office/drawing/2014/main" id="{FA47D11A-948F-4545-B61C-4C9B79C014DA}"/>
+                <a16:creationId xmlns:a16="http://schemas.microsoft.com/office/drawing/2014/main" id="{9C075DDC-5384-4684-8363-85C45773DA0D}"/>
               </a:ext>
             </a:extLst>
           </p:cNvPr>
@@ -10994,7 +10994,7 @@
           <p:cNvPr id="19" name="">
             <a:extLst xmlns:a="http://schemas.openxmlformats.org/drawingml/2006/main">
               <a:ext uri="{FF2B5EF4-FFF2-40B4-BE49-F238E27FC236}">
-                <a16:creationId xmlns:a16="http://schemas.microsoft.com/office/drawing/2014/main" id="{99178EB1-FF25-498F-99F2-B0824F5B6EF3}"/>
+                <a16:creationId xmlns:a16="http://schemas.microsoft.com/office/drawing/2014/main" id="{1D62D356-B938-4AE7-B967-2874CCADF9D5}"/>
               </a:ext>
             </a:extLst>
           </p:cNvPr>
@@ -11058,7 +11058,7 @@
           <p:cNvPr id="20" name="">
             <a:extLst xmlns:a="http://schemas.openxmlformats.org/drawingml/2006/main">
               <a:ext uri="{FF2B5EF4-FFF2-40B4-BE49-F238E27FC236}">
-                <a16:creationId xmlns:a16="http://schemas.microsoft.com/office/drawing/2014/main" id="{3C78C742-3D58-4330-A608-A773CBC45C66}"/>
+                <a16:creationId xmlns:a16="http://schemas.microsoft.com/office/drawing/2014/main" id="{C5079EFC-AAC8-4327-A1BC-20A3A5066EE6}"/>
               </a:ext>
             </a:extLst>
           </p:cNvPr>
@@ -11122,7 +11122,7 @@
           <p:cNvPr id="21" name="">
             <a:extLst xmlns:a="http://schemas.openxmlformats.org/drawingml/2006/main">
               <a:ext uri="{FF2B5EF4-FFF2-40B4-BE49-F238E27FC236}">
-                <a16:creationId xmlns:a16="http://schemas.microsoft.com/office/drawing/2014/main" id="{09A234F6-BB2C-4F19-8429-C9BB258C4604}"/>
+                <a16:creationId xmlns:a16="http://schemas.microsoft.com/office/drawing/2014/main" id="{67122C8E-A525-4A24-9A91-9C396AB52A9A}"/>
               </a:ext>
             </a:extLst>
           </p:cNvPr>
@@ -11184,7 +11184,7 @@
     </p:spTree>
     <p:extLst>
       <p:ext uri="{BB962C8B-B14F-4D97-AF65-F5344CB8AC3E}">
-        <p14:creationId xmlns:p14="http://schemas.microsoft.com/office/powerpoint/2010/main" val="457157107"/>
+        <p14:creationId xmlns:p14="http://schemas.microsoft.com/office/powerpoint/2010/main" val="159039968"/>
       </p:ext>
     </p:extLst>
   </p:cSld>
@@ -11208,7 +11208,7 @@
           <p:cNvPr id="1" name="">
             <a:extLst xmlns:a="http://schemas.openxmlformats.org/drawingml/2006/main">
               <a:ext uri="{FF2B5EF4-FFF2-40B4-BE49-F238E27FC236}">
-                <a16:creationId xmlns:a16="http://schemas.microsoft.com/office/drawing/2014/main" id="{F122EC75-4684-4ED5-99A9-5F4C30E2DDBA}"/>
+                <a16:creationId xmlns:a16="http://schemas.microsoft.com/office/drawing/2014/main" id="{35A00CB1-F848-4EFB-AB47-BDF03E49B6E9}"/>
               </a:ext>
             </a:extLst>
           </p:cNvPr>
@@ -11243,7 +11243,7 @@
           <p:cNvPr id="2" name="">
             <a:extLst xmlns:a="http://schemas.openxmlformats.org/drawingml/2006/main">
               <a:ext uri="{FF2B5EF4-FFF2-40B4-BE49-F238E27FC236}">
-                <a16:creationId xmlns:a16="http://schemas.microsoft.com/office/drawing/2014/main" id="{6C833B18-DE76-458B-A2EC-275C18AB21AB}"/>
+                <a16:creationId xmlns:a16="http://schemas.microsoft.com/office/drawing/2014/main" id="{4B68FACA-55B5-4897-9B45-CC879A9AD1E6}"/>
               </a:ext>
             </a:extLst>
           </p:cNvPr>
@@ -11307,7 +11307,7 @@
           <p:cNvPr id="3" name="">
             <a:extLst xmlns:a="http://schemas.openxmlformats.org/drawingml/2006/main">
               <a:ext uri="{FF2B5EF4-FFF2-40B4-BE49-F238E27FC236}">
-                <a16:creationId xmlns:a16="http://schemas.microsoft.com/office/drawing/2014/main" id="{2B60DDE3-FA5E-4AD2-8B92-3E11A58ECAAF}"/>
+                <a16:creationId xmlns:a16="http://schemas.microsoft.com/office/drawing/2014/main" id="{FFCEDB41-7535-4BB3-A414-47E7328DAC8B}"/>
               </a:ext>
             </a:extLst>
           </p:cNvPr>
@@ -11371,7 +11371,7 @@
           <p:cNvPr id="4" name="">
             <a:extLst xmlns:a="http://schemas.openxmlformats.org/drawingml/2006/main">
               <a:ext uri="{FF2B5EF4-FFF2-40B4-BE49-F238E27FC236}">
-                <a16:creationId xmlns:a16="http://schemas.microsoft.com/office/drawing/2014/main" id="{FF9BC57D-237A-45E8-990A-EBC42B4EDE82}"/>
+                <a16:creationId xmlns:a16="http://schemas.microsoft.com/office/drawing/2014/main" id="{7374879A-B8F9-4588-A816-6C72DA026B18}"/>
               </a:ext>
             </a:extLst>
           </p:cNvPr>
@@ -11435,7 +11435,7 @@
           <p:cNvPr id="5" name="">
             <a:extLst xmlns:a="http://schemas.openxmlformats.org/drawingml/2006/main">
               <a:ext uri="{FF2B5EF4-FFF2-40B4-BE49-F238E27FC236}">
-                <a16:creationId xmlns:a16="http://schemas.microsoft.com/office/drawing/2014/main" id="{C275CC74-8019-404E-8DB6-A2C33B691D59}"/>
+                <a16:creationId xmlns:a16="http://schemas.microsoft.com/office/drawing/2014/main" id="{D2951E55-B79C-4CF4-8354-89DD0F2001FF}"/>
               </a:ext>
             </a:extLst>
           </p:cNvPr>
@@ -11470,7 +11470,7 @@
           <p:cNvPr id="6" name="">
             <a:extLst xmlns:a="http://schemas.openxmlformats.org/drawingml/2006/main">
               <a:ext uri="{FF2B5EF4-FFF2-40B4-BE49-F238E27FC236}">
-                <a16:creationId xmlns:a16="http://schemas.microsoft.com/office/drawing/2014/main" id="{52F7F162-A2FF-4396-8905-90E7C06DE94E}"/>
+                <a16:creationId xmlns:a16="http://schemas.microsoft.com/office/drawing/2014/main" id="{DA448B49-E9EC-412B-8115-003AC0E03429}"/>
               </a:ext>
             </a:extLst>
           </p:cNvPr>
@@ -11503,7 +11503,7 @@
           <p:cNvPr id="7" name="">
             <a:extLst xmlns:a="http://schemas.openxmlformats.org/drawingml/2006/main">
               <a:ext uri="{FF2B5EF4-FFF2-40B4-BE49-F238E27FC236}">
-                <a16:creationId xmlns:a16="http://schemas.microsoft.com/office/drawing/2014/main" id="{3C2701A8-F3DB-43A9-8F27-3C4B864923A9}"/>
+                <a16:creationId xmlns:a16="http://schemas.microsoft.com/office/drawing/2014/main" id="{A50F424D-CB50-4537-B0C6-CF0F699FF4BD}"/>
               </a:ext>
             </a:extLst>
           </p:cNvPr>
@@ -11567,7 +11567,7 @@
           <p:cNvPr id="8" name="">
             <a:extLst xmlns:a="http://schemas.openxmlformats.org/drawingml/2006/main">
               <a:ext uri="{FF2B5EF4-FFF2-40B4-BE49-F238E27FC236}">
-                <a16:creationId xmlns:a16="http://schemas.microsoft.com/office/drawing/2014/main" id="{B112CE80-6739-41F0-A282-4582C6C7EA45}"/>
+                <a16:creationId xmlns:a16="http://schemas.microsoft.com/office/drawing/2014/main" id="{68DF3FFD-0BDF-4886-A2A4-96BA5EB11F4B}"/>
               </a:ext>
             </a:extLst>
           </p:cNvPr>
@@ -11631,7 +11631,7 @@
           <p:cNvPr id="9" name="">
             <a:extLst xmlns:a="http://schemas.openxmlformats.org/drawingml/2006/main">
               <a:ext uri="{FF2B5EF4-FFF2-40B4-BE49-F238E27FC236}">
-                <a16:creationId xmlns:a16="http://schemas.microsoft.com/office/drawing/2014/main" id="{4E6A0813-7852-41B6-B55C-D859344C83B7}"/>
+                <a16:creationId xmlns:a16="http://schemas.microsoft.com/office/drawing/2014/main" id="{2B3120E7-7F70-4E51-A7D7-6D3192DC18DC}"/>
               </a:ext>
             </a:extLst>
           </p:cNvPr>
@@ -11664,7 +11664,7 @@
           <p:cNvPr id="10" name="">
             <a:extLst xmlns:a="http://schemas.openxmlformats.org/drawingml/2006/main">
               <a:ext uri="{FF2B5EF4-FFF2-40B4-BE49-F238E27FC236}">
-                <a16:creationId xmlns:a16="http://schemas.microsoft.com/office/drawing/2014/main" id="{19C32ADF-C425-4BEC-B641-D1238126D568}"/>
+                <a16:creationId xmlns:a16="http://schemas.microsoft.com/office/drawing/2014/main" id="{E5B92DD9-AE56-4FB4-A2BC-969CD8D7B83A}"/>
               </a:ext>
             </a:extLst>
           </p:cNvPr>
@@ -11728,7 +11728,7 @@
           <p:cNvPr id="11" name="">
             <a:extLst xmlns:a="http://schemas.openxmlformats.org/drawingml/2006/main">
               <a:ext uri="{FF2B5EF4-FFF2-40B4-BE49-F238E27FC236}">
-                <a16:creationId xmlns:a16="http://schemas.microsoft.com/office/drawing/2014/main" id="{7CF565AB-7D9A-4446-8983-D7EDAD30B7EE}"/>
+                <a16:creationId xmlns:a16="http://schemas.microsoft.com/office/drawing/2014/main" id="{7A635EF2-2D06-411D-9AFB-A89F4D905109}"/>
               </a:ext>
             </a:extLst>
           </p:cNvPr>
@@ -11792,7 +11792,7 @@
           <p:cNvPr id="12" name="">
             <a:extLst xmlns:a="http://schemas.openxmlformats.org/drawingml/2006/main">
               <a:ext uri="{FF2B5EF4-FFF2-40B4-BE49-F238E27FC236}">
-                <a16:creationId xmlns:a16="http://schemas.microsoft.com/office/drawing/2014/main" id="{733E5AC5-6940-4F73-B957-C043FFBBEE8F}"/>
+                <a16:creationId xmlns:a16="http://schemas.microsoft.com/office/drawing/2014/main" id="{21C4FA0A-E0BC-4EF5-9F10-AFF6B963AFA2}"/>
               </a:ext>
             </a:extLst>
           </p:cNvPr>
@@ -11825,7 +11825,7 @@
           <p:cNvPr id="13" name="">
             <a:extLst xmlns:a="http://schemas.openxmlformats.org/drawingml/2006/main">
               <a:ext uri="{FF2B5EF4-FFF2-40B4-BE49-F238E27FC236}">
-                <a16:creationId xmlns:a16="http://schemas.microsoft.com/office/drawing/2014/main" id="{AFDA9EDD-F328-4661-A619-BB2B3A429251}"/>
+                <a16:creationId xmlns:a16="http://schemas.microsoft.com/office/drawing/2014/main" id="{63B6DD4D-BD5B-4F88-B0AD-AD4A04DF77B0}"/>
               </a:ext>
             </a:extLst>
           </p:cNvPr>
@@ -11889,7 +11889,7 @@
           <p:cNvPr id="14" name="">
             <a:extLst xmlns:a="http://schemas.openxmlformats.org/drawingml/2006/main">
               <a:ext uri="{FF2B5EF4-FFF2-40B4-BE49-F238E27FC236}">
-                <a16:creationId xmlns:a16="http://schemas.microsoft.com/office/drawing/2014/main" id="{2AD9BFC4-DE80-4730-A580-80DC87F518C8}"/>
+                <a16:creationId xmlns:a16="http://schemas.microsoft.com/office/drawing/2014/main" id="{4FBF2265-F1A8-4C9D-813A-0C9F82CA2C63}"/>
               </a:ext>
             </a:extLst>
           </p:cNvPr>
@@ -11953,7 +11953,7 @@
           <p:cNvPr id="15" name="">
             <a:extLst xmlns:a="http://schemas.openxmlformats.org/drawingml/2006/main">
               <a:ext uri="{FF2B5EF4-FFF2-40B4-BE49-F238E27FC236}">
-                <a16:creationId xmlns:a16="http://schemas.microsoft.com/office/drawing/2014/main" id="{B524A829-6D08-45A0-B88A-E617CC721802}"/>
+                <a16:creationId xmlns:a16="http://schemas.microsoft.com/office/drawing/2014/main" id="{37D47DF1-86DD-4CD4-AB3E-1FFE4E265CF1}"/>
               </a:ext>
             </a:extLst>
           </p:cNvPr>
@@ -11986,7 +11986,7 @@
           <p:cNvPr id="16" name="">
             <a:extLst xmlns:a="http://schemas.openxmlformats.org/drawingml/2006/main">
               <a:ext uri="{FF2B5EF4-FFF2-40B4-BE49-F238E27FC236}">
-                <a16:creationId xmlns:a16="http://schemas.microsoft.com/office/drawing/2014/main" id="{80B0A4C9-84D6-4471-B0AB-AEF0A7C3AA78}"/>
+                <a16:creationId xmlns:a16="http://schemas.microsoft.com/office/drawing/2014/main" id="{7BF2E68B-13F8-4CEB-9F15-CE7A908E2BC0}"/>
               </a:ext>
             </a:extLst>
           </p:cNvPr>
@@ -12050,7 +12050,7 @@
           <p:cNvPr id="17" name="">
             <a:extLst xmlns:a="http://schemas.openxmlformats.org/drawingml/2006/main">
               <a:ext uri="{FF2B5EF4-FFF2-40B4-BE49-F238E27FC236}">
-                <a16:creationId xmlns:a16="http://schemas.microsoft.com/office/drawing/2014/main" id="{CB5CB212-D106-4D70-891A-D699705036DE}"/>
+                <a16:creationId xmlns:a16="http://schemas.microsoft.com/office/drawing/2014/main" id="{285E274F-487F-4815-AD92-4A1A5A9915FF}"/>
               </a:ext>
             </a:extLst>
           </p:cNvPr>
@@ -12114,7 +12114,7 @@
           <p:cNvPr id="18" name="">
             <a:extLst xmlns:a="http://schemas.openxmlformats.org/drawingml/2006/main">
               <a:ext uri="{FF2B5EF4-FFF2-40B4-BE49-F238E27FC236}">
-                <a16:creationId xmlns:a16="http://schemas.microsoft.com/office/drawing/2014/main" id="{4C27FCF1-3F51-41A8-B22A-90BD0B1BB5FD}"/>
+                <a16:creationId xmlns:a16="http://schemas.microsoft.com/office/drawing/2014/main" id="{464CD61B-6CC0-4626-A292-1231D466AF8E}"/>
               </a:ext>
             </a:extLst>
           </p:cNvPr>
@@ -12147,7 +12147,7 @@
           <p:cNvPr id="19" name="">
             <a:extLst xmlns:a="http://schemas.openxmlformats.org/drawingml/2006/main">
               <a:ext uri="{FF2B5EF4-FFF2-40B4-BE49-F238E27FC236}">
-                <a16:creationId xmlns:a16="http://schemas.microsoft.com/office/drawing/2014/main" id="{4AD99236-0555-4F84-892C-DC1C55B313AC}"/>
+                <a16:creationId xmlns:a16="http://schemas.microsoft.com/office/drawing/2014/main" id="{C37BFA8C-4059-40F7-A66C-65D7D0FBBBA7}"/>
               </a:ext>
             </a:extLst>
           </p:cNvPr>
@@ -12211,7 +12211,7 @@
           <p:cNvPr id="20" name="">
             <a:extLst xmlns:a="http://schemas.openxmlformats.org/drawingml/2006/main">
               <a:ext uri="{FF2B5EF4-FFF2-40B4-BE49-F238E27FC236}">
-                <a16:creationId xmlns:a16="http://schemas.microsoft.com/office/drawing/2014/main" id="{87E2641A-C66B-46DF-9097-02FDB3DC384A}"/>
+                <a16:creationId xmlns:a16="http://schemas.microsoft.com/office/drawing/2014/main" id="{8C81EBE0-F1B1-4B44-8D1B-FBB0E386DA7B}"/>
               </a:ext>
             </a:extLst>
           </p:cNvPr>
@@ -12275,7 +12275,7 @@
           <p:cNvPr id="21" name="">
             <a:extLst xmlns:a="http://schemas.openxmlformats.org/drawingml/2006/main">
               <a:ext uri="{FF2B5EF4-FFF2-40B4-BE49-F238E27FC236}">
-                <a16:creationId xmlns:a16="http://schemas.microsoft.com/office/drawing/2014/main" id="{6485B595-1C46-4C71-BCF9-C2573D65A791}"/>
+                <a16:creationId xmlns:a16="http://schemas.microsoft.com/office/drawing/2014/main" id="{259F55AB-2DB5-499E-BF04-873E5B7E7B68}"/>
               </a:ext>
             </a:extLst>
           </p:cNvPr>
@@ -12337,7 +12337,7 @@
     </p:spTree>
     <p:extLst>
       <p:ext uri="{BB962C8B-B14F-4D97-AF65-F5344CB8AC3E}">
-        <p14:creationId xmlns:p14="http://schemas.microsoft.com/office/powerpoint/2010/main" val="579581213"/>
+        <p14:creationId xmlns:p14="http://schemas.microsoft.com/office/powerpoint/2010/main" val="1597269903"/>
       </p:ext>
     </p:extLst>
   </p:cSld>
@@ -12361,7 +12361,7 @@
           <p:cNvPr id="1" name="">
             <a:extLst xmlns:a="http://schemas.openxmlformats.org/drawingml/2006/main">
               <a:ext uri="{FF2B5EF4-FFF2-40B4-BE49-F238E27FC236}">
-                <a16:creationId xmlns:a16="http://schemas.microsoft.com/office/drawing/2014/main" id="{8262D60D-2D82-46F4-B75A-DFAF22F673AF}"/>
+                <a16:creationId xmlns:a16="http://schemas.microsoft.com/office/drawing/2014/main" id="{95C1024C-4432-4473-A576-18DFCC34298A}"/>
               </a:ext>
             </a:extLst>
           </p:cNvPr>
@@ -12396,7 +12396,7 @@
           <p:cNvPr id="2" name="">
             <a:extLst xmlns:a="http://schemas.openxmlformats.org/drawingml/2006/main">
               <a:ext uri="{FF2B5EF4-FFF2-40B4-BE49-F238E27FC236}">
-                <a16:creationId xmlns:a16="http://schemas.microsoft.com/office/drawing/2014/main" id="{D445452C-5B7B-48CE-AED2-ACE19AE573F8}"/>
+                <a16:creationId xmlns:a16="http://schemas.microsoft.com/office/drawing/2014/main" id="{716FE28B-0880-4993-8959-14D97F8059F5}"/>
               </a:ext>
             </a:extLst>
           </p:cNvPr>
@@ -12460,7 +12460,7 @@
           <p:cNvPr id="3" name="">
             <a:extLst xmlns:a="http://schemas.openxmlformats.org/drawingml/2006/main">
               <a:ext uri="{FF2B5EF4-FFF2-40B4-BE49-F238E27FC236}">
-                <a16:creationId xmlns:a16="http://schemas.microsoft.com/office/drawing/2014/main" id="{800FB0B1-395D-447F-A0DC-F83711F530D6}"/>
+                <a16:creationId xmlns:a16="http://schemas.microsoft.com/office/drawing/2014/main" id="{959DF445-AC81-474E-BF81-E70A87B59281}"/>
               </a:ext>
             </a:extLst>
           </p:cNvPr>
@@ -12524,7 +12524,7 @@
           <p:cNvPr id="4" name="">
             <a:extLst xmlns:a="http://schemas.openxmlformats.org/drawingml/2006/main">
               <a:ext uri="{FF2B5EF4-FFF2-40B4-BE49-F238E27FC236}">
-                <a16:creationId xmlns:a16="http://schemas.microsoft.com/office/drawing/2014/main" id="{B9DF2320-B06B-48B7-9E98-00F6679F5E95}"/>
+                <a16:creationId xmlns:a16="http://schemas.microsoft.com/office/drawing/2014/main" id="{827C632D-34E7-41AC-A97C-C39B73CF048A}"/>
               </a:ext>
             </a:extLst>
           </p:cNvPr>
@@ -12588,7 +12588,7 @@
           <p:cNvPr id="5" name="">
             <a:extLst xmlns:a="http://schemas.openxmlformats.org/drawingml/2006/main">
               <a:ext uri="{FF2B5EF4-FFF2-40B4-BE49-F238E27FC236}">
-                <a16:creationId xmlns:a16="http://schemas.microsoft.com/office/drawing/2014/main" id="{90C9FCED-AD13-47E9-B9E8-FE055BBF70A5}"/>
+                <a16:creationId xmlns:a16="http://schemas.microsoft.com/office/drawing/2014/main" id="{64D5C9BA-FA08-47AD-850A-D4C58678DDF0}"/>
               </a:ext>
             </a:extLst>
           </p:cNvPr>
@@ -12623,7 +12623,7 @@
           <p:cNvPr id="6" name="">
             <a:extLst xmlns:a="http://schemas.openxmlformats.org/drawingml/2006/main">
               <a:ext uri="{FF2B5EF4-FFF2-40B4-BE49-F238E27FC236}">
-                <a16:creationId xmlns:a16="http://schemas.microsoft.com/office/drawing/2014/main" id="{DBF37067-BDC3-4198-B273-2D4591079BBE}"/>
+                <a16:creationId xmlns:a16="http://schemas.microsoft.com/office/drawing/2014/main" id="{623C0897-B36F-400D-A3BB-1DED1B782597}"/>
               </a:ext>
             </a:extLst>
           </p:cNvPr>
@@ -12656,7 +12656,7 @@
           <p:cNvPr id="7" name="">
             <a:extLst xmlns:a="http://schemas.openxmlformats.org/drawingml/2006/main">
               <a:ext uri="{FF2B5EF4-FFF2-40B4-BE49-F238E27FC236}">
-                <a16:creationId xmlns:a16="http://schemas.microsoft.com/office/drawing/2014/main" id="{D0128192-0C75-4518-8C56-20E989A815ED}"/>
+                <a16:creationId xmlns:a16="http://schemas.microsoft.com/office/drawing/2014/main" id="{EB76478E-9526-4EAE-8C4F-41C7F9C5434C}"/>
               </a:ext>
             </a:extLst>
           </p:cNvPr>
@@ -12720,7 +12720,7 @@
           <p:cNvPr id="8" name="">
             <a:extLst xmlns:a="http://schemas.openxmlformats.org/drawingml/2006/main">
               <a:ext uri="{FF2B5EF4-FFF2-40B4-BE49-F238E27FC236}">
-                <a16:creationId xmlns:a16="http://schemas.microsoft.com/office/drawing/2014/main" id="{8F573A06-0BD9-412C-8034-0E018F118A2F}"/>
+                <a16:creationId xmlns:a16="http://schemas.microsoft.com/office/drawing/2014/main" id="{A5263A90-38B2-4270-93F8-CD7F28C8484A}"/>
               </a:ext>
             </a:extLst>
           </p:cNvPr>
@@ -12784,7 +12784,7 @@
           <p:cNvPr id="9" name="">
             <a:extLst xmlns:a="http://schemas.openxmlformats.org/drawingml/2006/main">
               <a:ext uri="{FF2B5EF4-FFF2-40B4-BE49-F238E27FC236}">
-                <a16:creationId xmlns:a16="http://schemas.microsoft.com/office/drawing/2014/main" id="{6E56B1E8-9B73-4AEF-AE74-CAF18814A460}"/>
+                <a16:creationId xmlns:a16="http://schemas.microsoft.com/office/drawing/2014/main" id="{937D8D22-DF46-417A-8FC4-06F1A3C1B985}"/>
               </a:ext>
             </a:extLst>
           </p:cNvPr>
@@ -12817,7 +12817,7 @@
           <p:cNvPr id="10" name="">
             <a:extLst xmlns:a="http://schemas.openxmlformats.org/drawingml/2006/main">
               <a:ext uri="{FF2B5EF4-FFF2-40B4-BE49-F238E27FC236}">
-                <a16:creationId xmlns:a16="http://schemas.microsoft.com/office/drawing/2014/main" id="{EDB82487-5C1C-451B-ACE2-835D44806D28}"/>
+                <a16:creationId xmlns:a16="http://schemas.microsoft.com/office/drawing/2014/main" id="{42753E20-CC40-46FE-BF40-553BF3D2983E}"/>
               </a:ext>
             </a:extLst>
           </p:cNvPr>
@@ -12881,7 +12881,7 @@
           <p:cNvPr id="11" name="">
             <a:extLst xmlns:a="http://schemas.openxmlformats.org/drawingml/2006/main">
               <a:ext uri="{FF2B5EF4-FFF2-40B4-BE49-F238E27FC236}">
-                <a16:creationId xmlns:a16="http://schemas.microsoft.com/office/drawing/2014/main" id="{519C4E70-FCA5-4871-8619-E32C7DA757D8}"/>
+                <a16:creationId xmlns:a16="http://schemas.microsoft.com/office/drawing/2014/main" id="{299C6916-92A8-4E0A-BD28-06F18036AEDF}"/>
               </a:ext>
             </a:extLst>
           </p:cNvPr>
@@ -12945,7 +12945,7 @@
           <p:cNvPr id="12" name="">
             <a:extLst xmlns:a="http://schemas.openxmlformats.org/drawingml/2006/main">
               <a:ext uri="{FF2B5EF4-FFF2-40B4-BE49-F238E27FC236}">
-                <a16:creationId xmlns:a16="http://schemas.microsoft.com/office/drawing/2014/main" id="{DE945712-DFE8-484D-86DD-BC565FD7FCC5}"/>
+                <a16:creationId xmlns:a16="http://schemas.microsoft.com/office/drawing/2014/main" id="{F9C97D1E-F407-4E04-AD4A-3EE9216EEB94}"/>
               </a:ext>
             </a:extLst>
           </p:cNvPr>
@@ -12978,7 +12978,7 @@
           <p:cNvPr id="13" name="">
             <a:extLst xmlns:a="http://schemas.openxmlformats.org/drawingml/2006/main">
               <a:ext uri="{FF2B5EF4-FFF2-40B4-BE49-F238E27FC236}">
-                <a16:creationId xmlns:a16="http://schemas.microsoft.com/office/drawing/2014/main" id="{9B40D488-095D-4E41-AEC8-632DC33EC149}"/>
+                <a16:creationId xmlns:a16="http://schemas.microsoft.com/office/drawing/2014/main" id="{A30AEDAB-323E-4B65-860A-E16040FFF6CD}"/>
               </a:ext>
             </a:extLst>
           </p:cNvPr>
@@ -13042,7 +13042,7 @@
           <p:cNvPr id="14" name="">
             <a:extLst xmlns:a="http://schemas.openxmlformats.org/drawingml/2006/main">
               <a:ext uri="{FF2B5EF4-FFF2-40B4-BE49-F238E27FC236}">
-                <a16:creationId xmlns:a16="http://schemas.microsoft.com/office/drawing/2014/main" id="{5254AFDE-25E9-47AC-A987-313EDD7096B2}"/>
+                <a16:creationId xmlns:a16="http://schemas.microsoft.com/office/drawing/2014/main" id="{ADF065F9-7BAC-4709-9C09-B514EFE55F01}"/>
               </a:ext>
             </a:extLst>
           </p:cNvPr>
@@ -13106,7 +13106,7 @@
           <p:cNvPr id="15" name="">
             <a:extLst xmlns:a="http://schemas.openxmlformats.org/drawingml/2006/main">
               <a:ext uri="{FF2B5EF4-FFF2-40B4-BE49-F238E27FC236}">
-                <a16:creationId xmlns:a16="http://schemas.microsoft.com/office/drawing/2014/main" id="{F2A9DC6C-36C8-4343-BB04-4A5AD3937533}"/>
+                <a16:creationId xmlns:a16="http://schemas.microsoft.com/office/drawing/2014/main" id="{B514A3BB-4FD9-4D81-9732-1C80F5D809F0}"/>
               </a:ext>
             </a:extLst>
           </p:cNvPr>
@@ -13139,7 +13139,7 @@
           <p:cNvPr id="16" name="">
             <a:extLst xmlns:a="http://schemas.openxmlformats.org/drawingml/2006/main">
               <a:ext uri="{FF2B5EF4-FFF2-40B4-BE49-F238E27FC236}">
-                <a16:creationId xmlns:a16="http://schemas.microsoft.com/office/drawing/2014/main" id="{AA3CC546-9D0E-45A5-A86A-60530336C17E}"/>
+                <a16:creationId xmlns:a16="http://schemas.microsoft.com/office/drawing/2014/main" id="{5930F281-E084-49E7-8712-8AAEEF347718}"/>
               </a:ext>
             </a:extLst>
           </p:cNvPr>
@@ -13203,7 +13203,7 @@
           <p:cNvPr id="17" name="">
             <a:extLst xmlns:a="http://schemas.openxmlformats.org/drawingml/2006/main">
               <a:ext uri="{FF2B5EF4-FFF2-40B4-BE49-F238E27FC236}">
-                <a16:creationId xmlns:a16="http://schemas.microsoft.com/office/drawing/2014/main" id="{0FA71C90-BDBB-4E5B-903C-683BE72D7E1B}"/>
+                <a16:creationId xmlns:a16="http://schemas.microsoft.com/office/drawing/2014/main" id="{4D898850-A6D8-4366-B308-884009760EAD}"/>
               </a:ext>
             </a:extLst>
           </p:cNvPr>
@@ -13267,7 +13267,7 @@
           <p:cNvPr id="18" name="">
             <a:extLst xmlns:a="http://schemas.openxmlformats.org/drawingml/2006/main">
               <a:ext uri="{FF2B5EF4-FFF2-40B4-BE49-F238E27FC236}">
-                <a16:creationId xmlns:a16="http://schemas.microsoft.com/office/drawing/2014/main" id="{7C85C2C7-0459-438D-9D1E-22BDE23704B7}"/>
+                <a16:creationId xmlns:a16="http://schemas.microsoft.com/office/drawing/2014/main" id="{97909CEF-28FE-4077-9E10-6036EA76651C}"/>
               </a:ext>
             </a:extLst>
           </p:cNvPr>
@@ -13331,7 +13331,7 @@
           <p:cNvPr id="19" name="">
             <a:extLst xmlns:a="http://schemas.openxmlformats.org/drawingml/2006/main">
               <a:ext uri="{FF2B5EF4-FFF2-40B4-BE49-F238E27FC236}">
-                <a16:creationId xmlns:a16="http://schemas.microsoft.com/office/drawing/2014/main" id="{78F992CB-6412-4DBD-8832-D88CE862F01B}"/>
+                <a16:creationId xmlns:a16="http://schemas.microsoft.com/office/drawing/2014/main" id="{AA93DF1F-4D89-473A-99E3-6314C98A9DCD}"/>
               </a:ext>
             </a:extLst>
           </p:cNvPr>
@@ -13393,7 +13393,7 @@
     </p:spTree>
     <p:extLst>
       <p:ext uri="{BB962C8B-B14F-4D97-AF65-F5344CB8AC3E}">
-        <p14:creationId xmlns:p14="http://schemas.microsoft.com/office/powerpoint/2010/main" val="1034349831"/>
+        <p14:creationId xmlns:p14="http://schemas.microsoft.com/office/powerpoint/2010/main" val="1539251739"/>
       </p:ext>
     </p:extLst>
   </p:cSld>

</xml_diff>